<commit_message>
docs: update on chain souvenir pitch wording
</commit_message>
<xml_diff>
--- a/docs/submission/pitch/tagtag-pitch.pptx
+++ b/docs/submission/pitch/tagtag-pitch.pptx
@@ -2,21 +2,21 @@
 <file path=ppt/presentation.xml><?xml version="1.0" encoding="utf-8"?>
 <p:presentation xmlns:p="http://schemas.openxmlformats.org/presentationml/2006/main">
   <p:sldMasterIdLst>
-    <p:sldMasterId xmlns:r="http://schemas.openxmlformats.org/officeDocument/2006/relationships" id="2147483648" r:id="Reee2bd7012814812"/>
+    <p:sldMasterId xmlns:r="http://schemas.openxmlformats.org/officeDocument/2006/relationships" id="2147483648" r:id="R658543d52aa249b8"/>
   </p:sldMasterIdLst>
   <p:notesMasterIdLst>
-    <p:notesMasterId xmlns:r="http://schemas.openxmlformats.org/officeDocument/2006/relationships" r:id="R57466864acd943ca"/>
+    <p:notesMasterId xmlns:r="http://schemas.openxmlformats.org/officeDocument/2006/relationships" r:id="R4a857c09b4074ca2"/>
   </p:notesMasterIdLst>
   <p:sldIdLst>
-    <p:sldId xmlns:r="http://schemas.openxmlformats.org/officeDocument/2006/relationships" id="256" r:id="R54f83eb7ab4542c9"/>
-    <p:sldId xmlns:r="http://schemas.openxmlformats.org/officeDocument/2006/relationships" id="257" r:id="R2ece24c86c7c4f81"/>
-    <p:sldId xmlns:r="http://schemas.openxmlformats.org/officeDocument/2006/relationships" id="258" r:id="R1add2fd9c2904ec4"/>
-    <p:sldId xmlns:r="http://schemas.openxmlformats.org/officeDocument/2006/relationships" id="259" r:id="R3ab536a0da944878"/>
-    <p:sldId xmlns:r="http://schemas.openxmlformats.org/officeDocument/2006/relationships" id="260" r:id="Rbeaf74d1f8ea42cd"/>
-    <p:sldId xmlns:r="http://schemas.openxmlformats.org/officeDocument/2006/relationships" id="261" r:id="Ra605d9e5470049d9"/>
-    <p:sldId xmlns:r="http://schemas.openxmlformats.org/officeDocument/2006/relationships" id="262" r:id="Rf5a4cf35c53f408f"/>
-    <p:sldId xmlns:r="http://schemas.openxmlformats.org/officeDocument/2006/relationships" id="263" r:id="R7b37278458774ab5"/>
-    <p:sldId xmlns:r="http://schemas.openxmlformats.org/officeDocument/2006/relationships" id="264" r:id="R4aca065d9daa4c0d"/>
+    <p:sldId xmlns:r="http://schemas.openxmlformats.org/officeDocument/2006/relationships" id="256" r:id="Rd6a90e22309f4966"/>
+    <p:sldId xmlns:r="http://schemas.openxmlformats.org/officeDocument/2006/relationships" id="257" r:id="R9e5c6544bce84255"/>
+    <p:sldId xmlns:r="http://schemas.openxmlformats.org/officeDocument/2006/relationships" id="258" r:id="R88cf291412884391"/>
+    <p:sldId xmlns:r="http://schemas.openxmlformats.org/officeDocument/2006/relationships" id="259" r:id="Ra63fbea262d94d5f"/>
+    <p:sldId xmlns:r="http://schemas.openxmlformats.org/officeDocument/2006/relationships" id="260" r:id="R5874a79e82f04196"/>
+    <p:sldId xmlns:r="http://schemas.openxmlformats.org/officeDocument/2006/relationships" id="261" r:id="Rf55e761eaeb84ee2"/>
+    <p:sldId xmlns:r="http://schemas.openxmlformats.org/officeDocument/2006/relationships" id="262" r:id="Reae7bf379ab64abf"/>
+    <p:sldId xmlns:r="http://schemas.openxmlformats.org/officeDocument/2006/relationships" id="263" r:id="Rd34f8fc34ac94555"/>
+    <p:sldId xmlns:r="http://schemas.openxmlformats.org/officeDocument/2006/relationships" id="264" r:id="Rb52dddecc23b4468"/>
   </p:sldIdLst>
   <p:sldSz cx="12192000" cy="6858000"/>
   <p:notesSz cx="6858000" cy="9144000"/>
@@ -1125,7 +1125,7 @@
           </a:p>
           <a:p xmlns:a="http://schemas.openxmlformats.org/drawingml/2006/main">
             <a:r>
-              <a:t>We also built an optional Ethereum Sepolia souvenir path. It remains disabled while we verify minting and wallets. The collecting experience works without a blockchain transaction.”</a:t>
+              <a:t>We have also implemented on chain souvenirs, bringing the idea of digital keepsakes into tagtag. The collecting experience works without a blockchain transaction.”</a:t>
             </a:r>
           </a:p>
           <a:p xmlns:a="http://schemas.openxmlformats.org/drawingml/2006/main">
@@ -1331,11 +1331,6 @@
           <a:p xmlns:a="http://schemas.openxmlformats.org/drawingml/2006/main">
             <a:r>
               <a:t>- Slide 6 reserves 75 seconds, including interaction and pauses. Keep the closing at 3:50 even if the demo runs slowly.</a:t>
-            </a:r>
-          </a:p>
-          <a:p xmlns:a="http://schemas.openxmlformats.org/drawingml/2006/main">
-            <a:r>
-              <a:t>- The repository currently sets `nftEnabled` to `false`. Keep slide 7’s statement unless a newer build and live acceptance evidence establish otherwise.</a:t>
             </a:r>
           </a:p>
           <a:p xmlns:a="http://schemas.openxmlformats.org/drawingml/2006/main">
@@ -1453,7 +1448,7 @@
   </p:cSld>
   <p:clrMap bg1="lt1" tx1="dk1" bg2="lt2" tx2="dk2" accent1="accent1" accent2="accent2" accent3="accent3" accent4="accent4" accent5="accent5" accent6="accent6" hlink="hlink" folHlink="folHlink"/>
   <p:sldLayoutIdLst>
-    <p:sldLayoutId xmlns:r="http://schemas.openxmlformats.org/officeDocument/2006/relationships" id="2147483649" r:id="R9550a6b7da2549fd"/>
+    <p:sldLayoutId xmlns:r="http://schemas.openxmlformats.org/officeDocument/2006/relationships" id="2147483649" r:id="R4b97dbdfd3174a1e"/>
   </p:sldLayoutIdLst>
   <p:txStyles>
     <p:titleStyle>
@@ -2004,7 +1999,7 @@
           <p:cNvPr id="7" name="tagtag">
             <a:extLst xmlns:a="http://schemas.openxmlformats.org/drawingml/2006/main">
               <a:ext uri="{FF2B5EF4-FFF2-40B4-BE49-F238E27FC236}">
-                <a16:creationId xmlns:a16="http://schemas.microsoft.com/office/drawing/2014/main" id="{DB7C9AF7-E405-4A36-A5F6-D14A03CFC2A3}"/>
+                <a16:creationId xmlns:a16="http://schemas.microsoft.com/office/drawing/2014/main" id="{8A3D3325-D22E-49ED-A209-318EDB917A6B}"/>
               </a:ext>
             </a:extLst>
           </p:cNvPr>
@@ -2061,7 +2056,7 @@
           <p:cNvPr id="2" name="An AR collecting game&#10;for communities">
             <a:extLst xmlns:a="http://schemas.openxmlformats.org/drawingml/2006/main">
               <a:ext uri="{FF2B5EF4-FFF2-40B4-BE49-F238E27FC236}">
-                <a16:creationId xmlns:a16="http://schemas.microsoft.com/office/drawing/2014/main" id="{CE8D7479-4F36-4EEA-8E13-60C60F172E2D}"/>
+                <a16:creationId xmlns:a16="http://schemas.microsoft.com/office/drawing/2014/main" id="{6F643B0B-1CC9-4448-8EBB-483FBD5128A2}"/>
               </a:ext>
             </a:extLst>
           </p:cNvPr>
@@ -2141,7 +2136,7 @@
           <p:cNvPr id="3" name="Find your places. Collect your moments.">
             <a:extLst xmlns:a="http://schemas.openxmlformats.org/drawingml/2006/main">
               <a:ext uri="{FF2B5EF4-FFF2-40B4-BE49-F238E27FC236}">
-                <a16:creationId xmlns:a16="http://schemas.microsoft.com/office/drawing/2014/main" id="{F6EA8D57-AFC1-4EA2-9FC8-3C89712B3F70}"/>
+                <a16:creationId xmlns:a16="http://schemas.microsoft.com/office/drawing/2014/main" id="{8A36AD42-0155-4D98-97A9-EA31FC4D4B26}"/>
               </a:ext>
             </a:extLst>
           </p:cNvPr>
@@ -2202,7 +2197,7 @@
           <p:nvPr/>
         </p:nvPicPr>
         <p:blipFill>
-          <a:blip xmlns:r="http://schemas.openxmlformats.org/officeDocument/2006/relationships" xmlns:a="http://schemas.openxmlformats.org/drawingml/2006/main" r:embed="Rc323f88e8cce4402"/>
+          <a:blip xmlns:r="http://schemas.openxmlformats.org/officeDocument/2006/relationships" xmlns:a="http://schemas.openxmlformats.org/drawingml/2006/main" r:embed="Rde51e5a14472491d"/>
           <a:stretch xmlns:a="http://schemas.openxmlformats.org/drawingml/2006/main"/>
         </p:blipFill>
         <p:spPr>
@@ -2220,7 +2215,7 @@
           <p:cNvPr id="5" name="ETHGlobal Tokyo 2026">
             <a:extLst xmlns:a="http://schemas.openxmlformats.org/drawingml/2006/main">
               <a:ext uri="{FF2B5EF4-FFF2-40B4-BE49-F238E27FC236}">
-                <a16:creationId xmlns:a16="http://schemas.microsoft.com/office/drawing/2014/main" id="{ED450121-3799-4954-8E96-CF27F9D2D52D}"/>
+                <a16:creationId xmlns:a16="http://schemas.microsoft.com/office/drawing/2014/main" id="{41D4FB68-4AA4-4827-8349-4BDBAD112562}"/>
               </a:ext>
             </a:extLst>
           </p:cNvPr>
@@ -2277,7 +2272,7 @@
           <p:cNvPr id="6" name="01">
             <a:extLst xmlns:a="http://schemas.openxmlformats.org/drawingml/2006/main">
               <a:ext uri="{FF2B5EF4-FFF2-40B4-BE49-F238E27FC236}">
-                <a16:creationId xmlns:a16="http://schemas.microsoft.com/office/drawing/2014/main" id="{8B4ED352-2CE1-479F-85D2-30E0E02937A3}"/>
+                <a16:creationId xmlns:a16="http://schemas.microsoft.com/office/drawing/2014/main" id="{60F8286C-CF2E-4EFD-88F9-25BAD5317E94}"/>
               </a:ext>
             </a:extLst>
           </p:cNvPr>
@@ -2332,7 +2327,7 @@
     </p:spTree>
     <p:extLst>
       <p:ext uri="{BB962C8B-B14F-4D97-AF65-F5344CB8AC3E}">
-        <p14:creationId xmlns:p14="http://schemas.microsoft.com/office/powerpoint/2010/main" val="55376069"/>
+        <p14:creationId xmlns:p14="http://schemas.microsoft.com/office/powerpoint/2010/main" val="1845626591"/>
       </p:ext>
     </p:extLst>
   </p:cSld>
@@ -2363,7 +2358,7 @@
           <p:cNvPr id="12" name="Two inspirations">
             <a:extLst xmlns:a="http://schemas.openxmlformats.org/drawingml/2006/main">
               <a:ext uri="{FF2B5EF4-FFF2-40B4-BE49-F238E27FC236}">
-                <a16:creationId xmlns:a16="http://schemas.microsoft.com/office/drawing/2014/main" id="{302C850B-8FC1-4842-8282-A8CAD45F15E4}"/>
+                <a16:creationId xmlns:a16="http://schemas.microsoft.com/office/drawing/2014/main" id="{3475C595-E530-4027-AF4E-47F3FB408653}"/>
               </a:ext>
             </a:extLst>
           </p:cNvPr>
@@ -2420,7 +2415,7 @@
           <p:cNvPr id="2" name="POAP">
             <a:extLst xmlns:a="http://schemas.openxmlformats.org/drawingml/2006/main">
               <a:ext uri="{FF2B5EF4-FFF2-40B4-BE49-F238E27FC236}">
-                <a16:creationId xmlns:a16="http://schemas.microsoft.com/office/drawing/2014/main" id="{9076BD7F-CC6F-4FE9-937B-754B73F485A1}"/>
+                <a16:creationId xmlns:a16="http://schemas.microsoft.com/office/drawing/2014/main" id="{66D1F7A7-74E6-4CB4-B026-14D19FE93BBA}"/>
               </a:ext>
             </a:extLst>
           </p:cNvPr>
@@ -2477,7 +2472,7 @@
           <p:cNvPr id="3" name="Memories worth keeping">
             <a:extLst xmlns:a="http://schemas.openxmlformats.org/drawingml/2006/main">
               <a:ext uri="{FF2B5EF4-FFF2-40B4-BE49-F238E27FC236}">
-                <a16:creationId xmlns:a16="http://schemas.microsoft.com/office/drawing/2014/main" id="{499F7E15-491F-4244-885B-1234A40F99D2}"/>
+                <a16:creationId xmlns:a16="http://schemas.microsoft.com/office/drawing/2014/main" id="{0190187C-DCA8-4033-B4ED-DCD0D7CC984D}"/>
               </a:ext>
             </a:extLst>
           </p:cNvPr>
@@ -2534,7 +2529,7 @@
           <p:cNvPr id="4" name="~7.6 million">
             <a:extLst xmlns:a="http://schemas.openxmlformats.org/drawingml/2006/main">
               <a:ext uri="{FF2B5EF4-FFF2-40B4-BE49-F238E27FC236}">
-                <a16:creationId xmlns:a16="http://schemas.microsoft.com/office/drawing/2014/main" id="{5529F5CE-5389-4BEE-8169-0213B41DEFB9}"/>
+                <a16:creationId xmlns:a16="http://schemas.microsoft.com/office/drawing/2014/main" id="{3FAEA1A8-4EB6-4444-9CE1-EB2D0BEB4944}"/>
               </a:ext>
             </a:extLst>
           </p:cNvPr>
@@ -2591,7 +2586,7 @@
           <p:cNvPr id="5" name="badges minted">
             <a:extLst xmlns:a="http://schemas.openxmlformats.org/drawingml/2006/main">
               <a:ext uri="{FF2B5EF4-FFF2-40B4-BE49-F238E27FC236}">
-                <a16:creationId xmlns:a16="http://schemas.microsoft.com/office/drawing/2014/main" id="{E159C67E-0B7E-4328-A700-B0988590E59D}"/>
+                <a16:creationId xmlns:a16="http://schemas.microsoft.com/office/drawing/2014/main" id="{053A32F6-80D6-4C46-832A-DF5E90CBC6F1}"/>
               </a:ext>
             </a:extLst>
           </p:cNvPr>
@@ -2648,7 +2643,7 @@
           <p:cNvPr id="6" name="46,210+ issuers">
             <a:extLst xmlns:a="http://schemas.openxmlformats.org/drawingml/2006/main">
               <a:ext uri="{FF2B5EF4-FFF2-40B4-BE49-F238E27FC236}">
-                <a16:creationId xmlns:a16="http://schemas.microsoft.com/office/drawing/2014/main" id="{1E122A76-4769-4259-9E3D-9FAE0A917522}"/>
+                <a16:creationId xmlns:a16="http://schemas.microsoft.com/office/drawing/2014/main" id="{D831787F-9012-497B-8180-822661E7C5FE}"/>
               </a:ext>
             </a:extLst>
           </p:cNvPr>
@@ -2705,7 +2700,7 @@
           <p:cNvPr id="7" name="Pokémon GO">
             <a:extLst xmlns:a="http://schemas.openxmlformats.org/drawingml/2006/main">
               <a:ext uri="{FF2B5EF4-FFF2-40B4-BE49-F238E27FC236}">
-                <a16:creationId xmlns:a16="http://schemas.microsoft.com/office/drawing/2014/main" id="{31A4D460-6D1F-43C2-8FF1-2678E9A37DAC}"/>
+                <a16:creationId xmlns:a16="http://schemas.microsoft.com/office/drawing/2014/main" id="{F4E95E89-BFCC-4B67-A22D-73272CD63927}"/>
               </a:ext>
             </a:extLst>
           </p:cNvPr>
@@ -2762,7 +2757,7 @@
           <p:cNvPr id="8" name="Discovery worth&#10;going out for">
             <a:extLst xmlns:a="http://schemas.openxmlformats.org/drawingml/2006/main">
               <a:ext uri="{FF2B5EF4-FFF2-40B4-BE49-F238E27FC236}">
-                <a16:creationId xmlns:a16="http://schemas.microsoft.com/office/drawing/2014/main" id="{7FA1E8E4-4042-4ED8-831D-DBE717C5FB29}"/>
+                <a16:creationId xmlns:a16="http://schemas.microsoft.com/office/drawing/2014/main" id="{1A6C2F16-E9D3-4073-9D0C-821291A315EF}"/>
               </a:ext>
             </a:extLst>
           </p:cNvPr>
@@ -2846,7 +2841,7 @@
           <p:nvPr/>
         </p:nvPicPr>
         <p:blipFill>
-          <a:blip xmlns:r="http://schemas.openxmlformats.org/officeDocument/2006/relationships" xmlns:a="http://schemas.openxmlformats.org/drawingml/2006/main" r:embed="R1d3bda443ffd4e81"/>
+          <a:blip xmlns:r="http://schemas.openxmlformats.org/officeDocument/2006/relationships" xmlns:a="http://schemas.openxmlformats.org/drawingml/2006/main" r:embed="R5b5dfd2e99c740f4"/>
           <a:stretch xmlns:a="http://schemas.openxmlformats.org/drawingml/2006/main"/>
         </p:blipFill>
         <p:spPr>
@@ -2864,7 +2859,7 @@
           <p:cNvPr id="10" name="Historical totals reported August 2026">
             <a:extLst xmlns:a="http://schemas.openxmlformats.org/drawingml/2006/main">
               <a:ext uri="{FF2B5EF4-FFF2-40B4-BE49-F238E27FC236}">
-                <a16:creationId xmlns:a16="http://schemas.microsoft.com/office/drawing/2014/main" id="{D95F1CF0-9E41-4F3D-8F44-1111DCE06FDC}"/>
+                <a16:creationId xmlns:a16="http://schemas.microsoft.com/office/drawing/2014/main" id="{FDC549A6-06F3-49B5-A9CE-78E6845A6F54}"/>
               </a:ext>
             </a:extLst>
           </p:cNvPr>
@@ -2921,7 +2916,7 @@
           <p:cNvPr id="11" name="02">
             <a:extLst xmlns:a="http://schemas.openxmlformats.org/drawingml/2006/main">
               <a:ext uri="{FF2B5EF4-FFF2-40B4-BE49-F238E27FC236}">
-                <a16:creationId xmlns:a16="http://schemas.microsoft.com/office/drawing/2014/main" id="{5B6FFE3F-FEAD-4F07-B659-F48C0E78A2B1}"/>
+                <a16:creationId xmlns:a16="http://schemas.microsoft.com/office/drawing/2014/main" id="{7EB6811F-05DB-46AD-84DC-47E9D872ADD2}"/>
               </a:ext>
             </a:extLst>
           </p:cNvPr>
@@ -2976,7 +2971,7 @@
     </p:spTree>
     <p:extLst>
       <p:ext uri="{BB962C8B-B14F-4D97-AF65-F5344CB8AC3E}">
-        <p14:creationId xmlns:p14="http://schemas.microsoft.com/office/powerpoint/2010/main" val="14950107"/>
+        <p14:creationId xmlns:p14="http://schemas.microsoft.com/office/powerpoint/2010/main" val="330907506"/>
       </p:ext>
     </p:extLst>
   </p:cSld>
@@ -3011,7 +3006,7 @@
           <p:nvPr/>
         </p:nvPicPr>
         <p:blipFill>
-          <a:blip xmlns:r="http://schemas.openxmlformats.org/officeDocument/2006/relationships" xmlns:a="http://schemas.openxmlformats.org/drawingml/2006/main" r:embed="R66dc0ba4673140ad"/>
+          <a:blip xmlns:r="http://schemas.openxmlformats.org/officeDocument/2006/relationships" xmlns:a="http://schemas.openxmlformats.org/drawingml/2006/main" r:embed="Rec758affe4034f3d"/>
           <a:stretch xmlns:a="http://schemas.openxmlformats.org/drawingml/2006/main"/>
         </p:blipFill>
         <p:spPr>
@@ -3029,7 +3024,7 @@
           <p:cNvPr id="2" name="A place has&#10;a story">
             <a:extLst xmlns:a="http://schemas.openxmlformats.org/drawingml/2006/main">
               <a:ext uri="{FF2B5EF4-FFF2-40B4-BE49-F238E27FC236}">
-                <a16:creationId xmlns:a16="http://schemas.microsoft.com/office/drawing/2014/main" id="{87670EA0-E35D-49C5-AC6F-0776CDFACBB8}"/>
+                <a16:creationId xmlns:a16="http://schemas.microsoft.com/office/drawing/2014/main" id="{A5EEA3CE-1DF0-40CF-ACBF-4F72966E44D3}"/>
               </a:ext>
             </a:extLst>
           </p:cNvPr>
@@ -3109,7 +3104,7 @@
           <p:cNvPr id="3" name="Leave a little discovery&#10;for the next person.">
             <a:extLst xmlns:a="http://schemas.openxmlformats.org/drawingml/2006/main">
               <a:ext uri="{FF2B5EF4-FFF2-40B4-BE49-F238E27FC236}">
-                <a16:creationId xmlns:a16="http://schemas.microsoft.com/office/drawing/2014/main" id="{5B113F2B-28BB-4A6B-9265-1773C3C15361}"/>
+                <a16:creationId xmlns:a16="http://schemas.microsoft.com/office/drawing/2014/main" id="{25043FFF-6303-43BC-9134-1B820CC3B39F}"/>
               </a:ext>
             </a:extLst>
           </p:cNvPr>
@@ -3189,7 +3184,7 @@
           <p:cNvPr id="4" name="App preview from iOS Simulator">
             <a:extLst xmlns:a="http://schemas.openxmlformats.org/drawingml/2006/main">
               <a:ext uri="{FF2B5EF4-FFF2-40B4-BE49-F238E27FC236}">
-                <a16:creationId xmlns:a16="http://schemas.microsoft.com/office/drawing/2014/main" id="{8BF163A1-11C6-483E-828D-EA9F983B9C23}"/>
+                <a16:creationId xmlns:a16="http://schemas.microsoft.com/office/drawing/2014/main" id="{397D6B5C-CD10-4F1E-A4CF-1CC8C73AA7AC}"/>
               </a:ext>
             </a:extLst>
           </p:cNvPr>
@@ -3246,7 +3241,7 @@
           <p:cNvPr id="5" name="03">
             <a:extLst xmlns:a="http://schemas.openxmlformats.org/drawingml/2006/main">
               <a:ext uri="{FF2B5EF4-FFF2-40B4-BE49-F238E27FC236}">
-                <a16:creationId xmlns:a16="http://schemas.microsoft.com/office/drawing/2014/main" id="{9089C32A-6918-453C-975B-F0995B81CF1A}"/>
+                <a16:creationId xmlns:a16="http://schemas.microsoft.com/office/drawing/2014/main" id="{A359F2B9-1D35-4356-8E03-A303A53682BE}"/>
               </a:ext>
             </a:extLst>
           </p:cNvPr>
@@ -3301,7 +3296,7 @@
     </p:spTree>
     <p:extLst>
       <p:ext uri="{BB962C8B-B14F-4D97-AF65-F5344CB8AC3E}">
-        <p14:creationId xmlns:p14="http://schemas.microsoft.com/office/powerpoint/2010/main" val="793357657"/>
+        <p14:creationId xmlns:p14="http://schemas.microsoft.com/office/powerpoint/2010/main" val="2075273739"/>
       </p:ext>
     </p:extLst>
   </p:cSld>
@@ -3332,7 +3327,7 @@
           <p:cNvPr id="12" name="The collecting loop">
             <a:extLst xmlns:a="http://schemas.openxmlformats.org/drawingml/2006/main">
               <a:ext uri="{FF2B5EF4-FFF2-40B4-BE49-F238E27FC236}">
-                <a16:creationId xmlns:a16="http://schemas.microsoft.com/office/drawing/2014/main" id="{85BB2DA9-663C-4E7D-91A6-7D8DD2550DD6}"/>
+                <a16:creationId xmlns:a16="http://schemas.microsoft.com/office/drawing/2014/main" id="{3AC9FB92-7432-4A78-97A3-B9B81402005B}"/>
               </a:ext>
             </a:extLst>
           </p:cNvPr>
@@ -3393,7 +3388,7 @@
           <p:nvPr/>
         </p:nvPicPr>
         <p:blipFill>
-          <a:blip xmlns:r="http://schemas.openxmlformats.org/officeDocument/2006/relationships" xmlns:a="http://schemas.openxmlformats.org/drawingml/2006/main" r:embed="R59daed44e71b488a"/>
+          <a:blip xmlns:r="http://schemas.openxmlformats.org/officeDocument/2006/relationships" xmlns:a="http://schemas.openxmlformats.org/drawingml/2006/main" r:embed="R32a42fb0ff2942b4"/>
           <a:stretch xmlns:a="http://schemas.openxmlformats.org/drawingml/2006/main"/>
         </p:blipFill>
         <p:spPr>
@@ -3415,7 +3410,7 @@
           <p:nvPr/>
         </p:nvPicPr>
         <p:blipFill>
-          <a:blip xmlns:r="http://schemas.openxmlformats.org/officeDocument/2006/relationships" xmlns:a="http://schemas.openxmlformats.org/drawingml/2006/main" r:embed="R67bf2cece88f44d8"/>
+          <a:blip xmlns:r="http://schemas.openxmlformats.org/officeDocument/2006/relationships" xmlns:a="http://schemas.openxmlformats.org/drawingml/2006/main" r:embed="R726c12754c7b4fc0"/>
           <a:stretch xmlns:a="http://schemas.openxmlformats.org/drawingml/2006/main"/>
         </p:blipFill>
         <p:spPr>
@@ -3437,7 +3432,7 @@
           <p:nvPr/>
         </p:nvPicPr>
         <p:blipFill>
-          <a:blip xmlns:r="http://schemas.openxmlformats.org/officeDocument/2006/relationships" xmlns:a="http://schemas.openxmlformats.org/drawingml/2006/main" r:embed="R6f28bc55f47b4178"/>
+          <a:blip xmlns:r="http://schemas.openxmlformats.org/officeDocument/2006/relationships" xmlns:a="http://schemas.openxmlformats.org/drawingml/2006/main" r:embed="R3e5ba97cadab4b3e"/>
           <a:stretch xmlns:a="http://schemas.openxmlformats.org/drawingml/2006/main"/>
         </p:blipFill>
         <p:spPr>
@@ -3455,7 +3450,7 @@
           <p:cNvPr id="5" name="1. Leave a sticker">
             <a:extLst xmlns:a="http://schemas.openxmlformats.org/drawingml/2006/main">
               <a:ext uri="{FF2B5EF4-FFF2-40B4-BE49-F238E27FC236}">
-                <a16:creationId xmlns:a16="http://schemas.microsoft.com/office/drawing/2014/main" id="{F7E13E92-AA1C-4EB3-9BB6-248A628E48FD}"/>
+                <a16:creationId xmlns:a16="http://schemas.microsoft.com/office/drawing/2014/main" id="{A6BF35EA-E871-425C-9F56-D4C73BF0A8D9}"/>
               </a:ext>
             </a:extLst>
           </p:cNvPr>
@@ -3512,7 +3507,7 @@
           <p:cNvPr id="6" name="Art, a place, a private note.">
             <a:extLst xmlns:a="http://schemas.openxmlformats.org/drawingml/2006/main">
               <a:ext uri="{FF2B5EF4-FFF2-40B4-BE49-F238E27FC236}">
-                <a16:creationId xmlns:a16="http://schemas.microsoft.com/office/drawing/2014/main" id="{4A87569C-C879-41DF-AB44-E66197F79AF2}"/>
+                <a16:creationId xmlns:a16="http://schemas.microsoft.com/office/drawing/2014/main" id="{A2723D09-456B-40E8-93F4-5C9B0D4AA82B}"/>
               </a:ext>
             </a:extLst>
           </p:cNvPr>
@@ -3569,7 +3564,7 @@
           <p:cNvPr id="7" name="2. Find its place">
             <a:extLst xmlns:a="http://schemas.openxmlformats.org/drawingml/2006/main">
               <a:ext uri="{FF2B5EF4-FFF2-40B4-BE49-F238E27FC236}">
-                <a16:creationId xmlns:a16="http://schemas.microsoft.com/office/drawing/2014/main" id="{EAECA2B8-8A76-4CA4-90F6-7524EC168244}"/>
+                <a16:creationId xmlns:a16="http://schemas.microsoft.com/office/drawing/2014/main" id="{CDE1451D-604E-49B2-843A-F15259184D37}"/>
               </a:ext>
             </a:extLst>
           </p:cNvPr>
@@ -3626,7 +3621,7 @@
           <p:cNvPr id="8" name="Follow the clue into AR.">
             <a:extLst xmlns:a="http://schemas.openxmlformats.org/drawingml/2006/main">
               <a:ext uri="{FF2B5EF4-FFF2-40B4-BE49-F238E27FC236}">
-                <a16:creationId xmlns:a16="http://schemas.microsoft.com/office/drawing/2014/main" id="{4A98F25A-CC0F-4CA4-A560-99658D721FB2}"/>
+                <a16:creationId xmlns:a16="http://schemas.microsoft.com/office/drawing/2014/main" id="{3E8B6DE3-FEB6-4903-953E-C38424CA579A}"/>
               </a:ext>
             </a:extLst>
           </p:cNvPr>
@@ -3683,7 +3678,7 @@
           <p:cNvPr id="9" name="3. Keep the memory">
             <a:extLst xmlns:a="http://schemas.openxmlformats.org/drawingml/2006/main">
               <a:ext uri="{FF2B5EF4-FFF2-40B4-BE49-F238E27FC236}">
-                <a16:creationId xmlns:a16="http://schemas.microsoft.com/office/drawing/2014/main" id="{866F27A9-1CA4-4AFE-A149-7EA6D6064012}"/>
+                <a16:creationId xmlns:a16="http://schemas.microsoft.com/office/drawing/2014/main" id="{FDA0BFE9-FBB0-4C2E-811E-732C010B13C2}"/>
               </a:ext>
             </a:extLst>
           </p:cNvPr>
@@ -3740,7 +3735,7 @@
           <p:cNvPr id="10" name="Collect a copy. Reveal the note.">
             <a:extLst xmlns:a="http://schemas.openxmlformats.org/drawingml/2006/main">
               <a:ext uri="{FF2B5EF4-FFF2-40B4-BE49-F238E27FC236}">
-                <a16:creationId xmlns:a16="http://schemas.microsoft.com/office/drawing/2014/main" id="{DA6F7A4E-C13D-42B4-BF4C-389D94547672}"/>
+                <a16:creationId xmlns:a16="http://schemas.microsoft.com/office/drawing/2014/main" id="{2D84635F-B701-4640-B472-94C341770CE7}"/>
               </a:ext>
             </a:extLst>
           </p:cNvPr>
@@ -3797,7 +3792,7 @@
           <p:cNvPr id="11" name="04">
             <a:extLst xmlns:a="http://schemas.openxmlformats.org/drawingml/2006/main">
               <a:ext uri="{FF2B5EF4-FFF2-40B4-BE49-F238E27FC236}">
-                <a16:creationId xmlns:a16="http://schemas.microsoft.com/office/drawing/2014/main" id="{3D7C98DC-295E-49B8-9E29-A4A052B9710D}"/>
+                <a16:creationId xmlns:a16="http://schemas.microsoft.com/office/drawing/2014/main" id="{790F6DB7-EA53-411E-AD68-719932D6DB62}"/>
               </a:ext>
             </a:extLst>
           </p:cNvPr>
@@ -3852,7 +3847,7 @@
     </p:spTree>
     <p:extLst>
       <p:ext uri="{BB962C8B-B14F-4D97-AF65-F5344CB8AC3E}">
-        <p14:creationId xmlns:p14="http://schemas.microsoft.com/office/powerpoint/2010/main" val="450436970"/>
+        <p14:creationId xmlns:p14="http://schemas.microsoft.com/office/powerpoint/2010/main" val="6549200"/>
       </p:ext>
     </p:extLst>
   </p:cSld>
@@ -3883,7 +3878,7 @@
           <p:cNvPr id="9" name="A game communities&#10;can make their own">
             <a:extLst xmlns:a="http://schemas.openxmlformats.org/drawingml/2006/main">
               <a:ext uri="{FF2B5EF4-FFF2-40B4-BE49-F238E27FC236}">
-                <a16:creationId xmlns:a16="http://schemas.microsoft.com/office/drawing/2014/main" id="{51C40343-1D09-4F1A-95F2-5C3F39F4DFE2}"/>
+                <a16:creationId xmlns:a16="http://schemas.microsoft.com/office/drawing/2014/main" id="{2A0F6FD0-EEA9-4801-BFAA-A4546F3D6C66}"/>
               </a:ext>
             </a:extLst>
           </p:cNvPr>
@@ -3963,7 +3958,7 @@
           <p:cNvPr id="2" name="A conference’s gathering places">
             <a:extLst xmlns:a="http://schemas.openxmlformats.org/drawingml/2006/main">
               <a:ext uri="{FF2B5EF4-FFF2-40B4-BE49-F238E27FC236}">
-                <a16:creationId xmlns:a16="http://schemas.microsoft.com/office/drawing/2014/main" id="{EB25EF99-2171-43B9-91BC-8818805B8225}"/>
+                <a16:creationId xmlns:a16="http://schemas.microsoft.com/office/drawing/2014/main" id="{6399642F-AA79-437C-9258-83B41F6A4308}"/>
               </a:ext>
             </a:extLst>
           </p:cNvPr>
@@ -4020,7 +4015,7 @@
           <p:cNvPr id="3" name="A neighbourhood’s art walk">
             <a:extLst xmlns:a="http://schemas.openxmlformats.org/drawingml/2006/main">
               <a:ext uri="{FF2B5EF4-FFF2-40B4-BE49-F238E27FC236}">
-                <a16:creationId xmlns:a16="http://schemas.microsoft.com/office/drawing/2014/main" id="{779445B7-3F88-430F-9540-22C6C654FCE0}"/>
+                <a16:creationId xmlns:a16="http://schemas.microsoft.com/office/drawing/2014/main" id="{D71982D1-1D36-400F-A745-88B980F8ADD6}"/>
               </a:ext>
             </a:extLst>
           </p:cNvPr>
@@ -4077,7 +4072,7 @@
           <p:cNvPr id="4" name="Shared discoveries give people&#10;a reason to meet and ret">
             <a:extLst xmlns:a="http://schemas.openxmlformats.org/drawingml/2006/main">
               <a:ext uri="{FF2B5EF4-FFF2-40B4-BE49-F238E27FC236}">
-                <a16:creationId xmlns:a16="http://schemas.microsoft.com/office/drawing/2014/main" id="{AAE1A355-5482-43A5-9E57-31E21FAF29BC}"/>
+                <a16:creationId xmlns:a16="http://schemas.microsoft.com/office/drawing/2014/main" id="{C8B20467-2CAC-4A10-A229-A7A050215338}"/>
               </a:ext>
             </a:extLst>
           </p:cNvPr>
@@ -4161,7 +4156,7 @@
           <p:nvPr/>
         </p:nvPicPr>
         <p:blipFill>
-          <a:blip xmlns:r="http://schemas.openxmlformats.org/officeDocument/2006/relationships" xmlns:a="http://schemas.openxmlformats.org/drawingml/2006/main" r:embed="R6aa50bd71931491b"/>
+          <a:blip xmlns:r="http://schemas.openxmlformats.org/officeDocument/2006/relationships" xmlns:a="http://schemas.openxmlformats.org/drawingml/2006/main" r:embed="Rc38da9b3b10942b1"/>
           <a:stretch xmlns:a="http://schemas.openxmlformats.org/drawingml/2006/main"/>
         </p:blipFill>
         <p:spPr>
@@ -4179,7 +4174,7 @@
           <p:cNvPr id="6" name="Proposed uses">
             <a:extLst xmlns:a="http://schemas.openxmlformats.org/drawingml/2006/main">
               <a:ext uri="{FF2B5EF4-FFF2-40B4-BE49-F238E27FC236}">
-                <a16:creationId xmlns:a16="http://schemas.microsoft.com/office/drawing/2014/main" id="{A1633C06-2097-4D06-89F3-63CCA21BCC68}"/>
+                <a16:creationId xmlns:a16="http://schemas.microsoft.com/office/drawing/2014/main" id="{746F4926-5B54-466D-8342-5EBDD1C54DCF}"/>
               </a:ext>
             </a:extLst>
           </p:cNvPr>
@@ -4236,7 +4231,7 @@
           <p:cNvPr id="7" name="UI preview / sample data">
             <a:extLst xmlns:a="http://schemas.openxmlformats.org/drawingml/2006/main">
               <a:ext uri="{FF2B5EF4-FFF2-40B4-BE49-F238E27FC236}">
-                <a16:creationId xmlns:a16="http://schemas.microsoft.com/office/drawing/2014/main" id="{20B570B0-D4C2-4C0E-B0A9-8EB4735F98FF}"/>
+                <a16:creationId xmlns:a16="http://schemas.microsoft.com/office/drawing/2014/main" id="{E8221F4F-F525-4CCD-8218-B20CC99A9A3E}"/>
               </a:ext>
             </a:extLst>
           </p:cNvPr>
@@ -4293,7 +4288,7 @@
           <p:cNvPr id="8" name="05">
             <a:extLst xmlns:a="http://schemas.openxmlformats.org/drawingml/2006/main">
               <a:ext uri="{FF2B5EF4-FFF2-40B4-BE49-F238E27FC236}">
-                <a16:creationId xmlns:a16="http://schemas.microsoft.com/office/drawing/2014/main" id="{40AD3E33-F284-4523-AB58-F33F30FBD956}"/>
+                <a16:creationId xmlns:a16="http://schemas.microsoft.com/office/drawing/2014/main" id="{1A3898DF-E8C6-4E74-BFE1-D0587E7AD225}"/>
               </a:ext>
             </a:extLst>
           </p:cNvPr>
@@ -4348,7 +4343,7 @@
     </p:spTree>
     <p:extLst>
       <p:ext uri="{BB962C8B-B14F-4D97-AF65-F5344CB8AC3E}">
-        <p14:creationId xmlns:p14="http://schemas.microsoft.com/office/powerpoint/2010/main" val="1468319171"/>
+        <p14:creationId xmlns:p14="http://schemas.microsoft.com/office/powerpoint/2010/main" val="1899809556"/>
       </p:ext>
     </p:extLst>
   </p:cSld>
@@ -4379,7 +4374,7 @@
           <p:cNvPr id="5" name="DEMO">
             <a:extLst xmlns:a="http://schemas.openxmlformats.org/drawingml/2006/main">
               <a:ext uri="{FF2B5EF4-FFF2-40B4-BE49-F238E27FC236}">
-                <a16:creationId xmlns:a16="http://schemas.microsoft.com/office/drawing/2014/main" id="{83F73773-390B-4EC6-9E99-E939EE74D99F}"/>
+                <a16:creationId xmlns:a16="http://schemas.microsoft.com/office/drawing/2014/main" id="{06E7A693-1D0D-4E72-81DB-EF5A4D603C41}"/>
               </a:ext>
             </a:extLst>
           </p:cNvPr>
@@ -4440,7 +4435,7 @@
           <p:nvPr/>
         </p:nvPicPr>
         <p:blipFill>
-          <a:blip xmlns:r="http://schemas.openxmlformats.org/officeDocument/2006/relationships" xmlns:a="http://schemas.openxmlformats.org/drawingml/2006/main" r:embed="R9be05a6edc574144"/>
+          <a:blip xmlns:r="http://schemas.openxmlformats.org/officeDocument/2006/relationships" xmlns:a="http://schemas.openxmlformats.org/drawingml/2006/main" r:embed="R36ce049c2c5040ba"/>
           <a:stretch xmlns:a="http://schemas.openxmlformats.org/drawingml/2006/main"/>
         </p:blipFill>
         <p:spPr>
@@ -4458,7 +4453,7 @@
           <p:cNvPr id="3" name="A little discovery, in the real world">
             <a:extLst xmlns:a="http://schemas.openxmlformats.org/drawingml/2006/main">
               <a:ext uri="{FF2B5EF4-FFF2-40B4-BE49-F238E27FC236}">
-                <a16:creationId xmlns:a16="http://schemas.microsoft.com/office/drawing/2014/main" id="{35C5B582-7AB1-487D-A94C-AFA1EA00585C}"/>
+                <a16:creationId xmlns:a16="http://schemas.microsoft.com/office/drawing/2014/main" id="{A94B4B20-186B-4F00-9922-43FFE8C3579E}"/>
               </a:ext>
             </a:extLst>
           </p:cNvPr>
@@ -4515,7 +4510,7 @@
           <p:cNvPr id="4" name="06">
             <a:extLst xmlns:a="http://schemas.openxmlformats.org/drawingml/2006/main">
               <a:ext uri="{FF2B5EF4-FFF2-40B4-BE49-F238E27FC236}">
-                <a16:creationId xmlns:a16="http://schemas.microsoft.com/office/drawing/2014/main" id="{F7BF55DD-4698-4AC0-93AC-DDCDD3D27C4A}"/>
+                <a16:creationId xmlns:a16="http://schemas.microsoft.com/office/drawing/2014/main" id="{38850924-AD1D-45B7-B5F3-D4EAC1711B53}"/>
               </a:ext>
             </a:extLst>
           </p:cNvPr>
@@ -4570,7 +4565,7 @@
     </p:spTree>
     <p:extLst>
       <p:ext uri="{BB962C8B-B14F-4D97-AF65-F5344CB8AC3E}">
-        <p14:creationId xmlns:p14="http://schemas.microsoft.com/office/powerpoint/2010/main" val="637900758"/>
+        <p14:creationId xmlns:p14="http://schemas.microsoft.com/office/powerpoint/2010/main" val="1752351793"/>
       </p:ext>
     </p:extLst>
   </p:cSld>
@@ -4601,7 +4596,7 @@
           <p:cNvPr id="12" name="How it works">
             <a:extLst xmlns:a="http://schemas.openxmlformats.org/drawingml/2006/main">
               <a:ext uri="{FF2B5EF4-FFF2-40B4-BE49-F238E27FC236}">
-                <a16:creationId xmlns:a16="http://schemas.microsoft.com/office/drawing/2014/main" id="{DA114AA5-DF08-4859-9099-0A823F011173}"/>
+                <a16:creationId xmlns:a16="http://schemas.microsoft.com/office/drawing/2014/main" id="{E84FAE9A-6F1E-494B-9226-20B862DCE568}"/>
               </a:ext>
             </a:extLst>
           </p:cNvPr>
@@ -4658,7 +4653,7 @@
           <p:cNvPr id="2" name="Unity + ARKit">
             <a:extLst xmlns:a="http://schemas.openxmlformats.org/drawingml/2006/main">
               <a:ext uri="{FF2B5EF4-FFF2-40B4-BE49-F238E27FC236}">
-                <a16:creationId xmlns:a16="http://schemas.microsoft.com/office/drawing/2014/main" id="{E270149E-B20E-4D78-B0E8-780FB2FC864A}"/>
+                <a16:creationId xmlns:a16="http://schemas.microsoft.com/office/drawing/2014/main" id="{42842688-7C30-4118-8D4D-A602A52FD5F0}"/>
               </a:ext>
             </a:extLst>
           </p:cNvPr>
@@ -4715,7 +4710,7 @@
           <p:cNvPr id="3" name="Place and recover stickers in AR">
             <a:extLst xmlns:a="http://schemas.openxmlformats.org/drawingml/2006/main">
               <a:ext uri="{FF2B5EF4-FFF2-40B4-BE49-F238E27FC236}">
-                <a16:creationId xmlns:a16="http://schemas.microsoft.com/office/drawing/2014/main" id="{5FB98EEA-2058-4937-9D59-58925D32B223}"/>
+                <a16:creationId xmlns:a16="http://schemas.microsoft.com/office/drawing/2014/main" id="{D0961ECF-BA39-453D-9400-E64AA58439E9}"/>
               </a:ext>
             </a:extLst>
           </p:cNvPr>
@@ -4772,7 +4767,7 @@
           <p:cNvPr id="4" name="MapKit">
             <a:extLst xmlns:a="http://schemas.openxmlformats.org/drawingml/2006/main">
               <a:ext uri="{FF2B5EF4-FFF2-40B4-BE49-F238E27FC236}">
-                <a16:creationId xmlns:a16="http://schemas.microsoft.com/office/drawing/2014/main" id="{2CC3A064-E996-40F5-AAE1-65AE305E276F}"/>
+                <a16:creationId xmlns:a16="http://schemas.microsoft.com/office/drawing/2014/main" id="{F0A70D8D-E84C-4EA4-B671-5DB2467F7C5A}"/>
               </a:ext>
             </a:extLst>
           </p:cNvPr>
@@ -4829,7 +4824,7 @@
           <p:cNvPr id="5" name="Nearby discovery on Apple’s maps">
             <a:extLst xmlns:a="http://schemas.openxmlformats.org/drawingml/2006/main">
               <a:ext uri="{FF2B5EF4-FFF2-40B4-BE49-F238E27FC236}">
-                <a16:creationId xmlns:a16="http://schemas.microsoft.com/office/drawing/2014/main" id="{83A89081-2425-4DD0-849A-3DD7702FCD42}"/>
+                <a16:creationId xmlns:a16="http://schemas.microsoft.com/office/drawing/2014/main" id="{8E6C682A-4033-4841-91FC-EA575793A02D}"/>
               </a:ext>
             </a:extLst>
           </p:cNvPr>
@@ -4886,7 +4881,7 @@
           <p:cNvPr id="6" name="Firebase + Cloud Run">
             <a:extLst xmlns:a="http://schemas.openxmlformats.org/drawingml/2006/main">
               <a:ext uri="{FF2B5EF4-FFF2-40B4-BE49-F238E27FC236}">
-                <a16:creationId xmlns:a16="http://schemas.microsoft.com/office/drawing/2014/main" id="{48EE7160-309A-441C-AE58-1961DABBE0E2}"/>
+                <a16:creationId xmlns:a16="http://schemas.microsoft.com/office/drawing/2014/main" id="{AF8B48DB-296B-4F2B-9E00-49FF0DA3F731}"/>
               </a:ext>
             </a:extLst>
           </p:cNvPr>
@@ -4943,7 +4938,7 @@
           <p:cNvPr id="7" name="Stickers, collections and private notes">
             <a:extLst xmlns:a="http://schemas.openxmlformats.org/drawingml/2006/main">
               <a:ext uri="{FF2B5EF4-FFF2-40B4-BE49-F238E27FC236}">
-                <a16:creationId xmlns:a16="http://schemas.microsoft.com/office/drawing/2014/main" id="{EE1E599C-05D7-4E3B-BB7C-A5CE14B0FEB3}"/>
+                <a16:creationId xmlns:a16="http://schemas.microsoft.com/office/drawing/2014/main" id="{75E23F27-04A3-4C09-B2D5-C50C0292388C}"/>
               </a:ext>
             </a:extLst>
           </p:cNvPr>
@@ -5004,7 +4999,7 @@
           <p:nvPr/>
         </p:nvPicPr>
         <p:blipFill>
-          <a:blip xmlns:r="http://schemas.openxmlformats.org/officeDocument/2006/relationships" xmlns:a="http://schemas.openxmlformats.org/drawingml/2006/main" r:embed="Re54fd0be4e304e5f"/>
+          <a:blip xmlns:r="http://schemas.openxmlformats.org/officeDocument/2006/relationships" xmlns:a="http://schemas.openxmlformats.org/drawingml/2006/main" r:embed="R2db394a46445471d"/>
           <a:stretch xmlns:a="http://schemas.openxmlformats.org/drawingml/2006/main"/>
         </p:blipFill>
         <p:spPr>
@@ -5019,10 +5014,10 @@
       </p:pic>
       <p:sp>
         <p:nvSpPr>
-          <p:cNvPr id="9" name="Optional Sepolia souvenirs">
+          <p:cNvPr id="9" name="On chain souvenirs">
             <a:extLst xmlns:a="http://schemas.openxmlformats.org/drawingml/2006/main">
               <a:ext uri="{FF2B5EF4-FFF2-40B4-BE49-F238E27FC236}">
-                <a16:creationId xmlns:a16="http://schemas.microsoft.com/office/drawing/2014/main" id="{68A8A369-283B-4A27-AD41-137C8DF79915}"/>
+                <a16:creationId xmlns:a16="http://schemas.microsoft.com/office/drawing/2014/main" id="{F49427DD-3AEE-4D5D-BA60-CAA7830324F5}"/>
               </a:ext>
             </a:extLst>
           </p:cNvPr>
@@ -5069,17 +5064,17 @@
                 <a:ea typeface="Shadows Into Light"/>
                 <a:cs typeface="Shadows Into Light"/>
               </a:rPr>
-              <a:t>Optional Sepolia souvenirs</a:t>
-            </a:r>
-          </a:p>
-        </p:txBody>
-      </p:sp>
-      <p:sp>
-        <p:nvSpPr>
-          <p:cNvPr id="10" name="Implemented, disabled&#10;pending verification">
+              <a:t>On chain souvenirs</a:t>
+            </a:r>
+          </a:p>
+        </p:txBody>
+      </p:sp>
+      <p:sp>
+        <p:nvSpPr>
+          <p:cNvPr id="10" name="Already implemented">
             <a:extLst xmlns:a="http://schemas.openxmlformats.org/drawingml/2006/main">
               <a:ext uri="{FF2B5EF4-FFF2-40B4-BE49-F238E27FC236}">
-                <a16:creationId xmlns:a16="http://schemas.microsoft.com/office/drawing/2014/main" id="{0D61EAC0-5942-4D80-85EF-C4CD3854FC01}"/>
+                <a16:creationId xmlns:a16="http://schemas.microsoft.com/office/drawing/2014/main" id="{53C31EE2-7B22-4ECA-AB91-9C6E50107932}"/>
               </a:ext>
             </a:extLst>
           </p:cNvPr>
@@ -5126,30 +5121,7 @@
                 <a:ea typeface="Instrument Sans"/>
                 <a:cs typeface="Instrument Sans"/>
               </a:rPr>
-              <a:t>Implemented, disabled</a:t>
-            </a:r>
-          </a:p>
-          <a:p xmlns:a="http://schemas.openxmlformats.org/drawingml/2006/main">
-            <a:pPr>
-              <a:defRPr sz="1725">
-                <a:solidFill>
-                  <a:srgbClr val="62625B"/>
-                </a:solidFill>
-                <a:latin typeface="Instrument Sans"/>
-                <a:ea typeface="Instrument Sans"/>
-                <a:cs typeface="Instrument Sans"/>
-              </a:defRPr>
-            </a:pPr>
-            <a:r>
-              <a:rPr sz="1725">
-                <a:solidFill>
-                  <a:srgbClr val="62625B"/>
-                </a:solidFill>
-                <a:latin typeface="Instrument Sans"/>
-                <a:ea typeface="Instrument Sans"/>
-                <a:cs typeface="Instrument Sans"/>
-              </a:rPr>
-              <a:t>pending verification</a:t>
+              <a:t>Already implemented</a:t>
             </a:r>
           </a:p>
         </p:txBody>
@@ -5159,7 +5131,7 @@
           <p:cNvPr id="11" name="07">
             <a:extLst xmlns:a="http://schemas.openxmlformats.org/drawingml/2006/main">
               <a:ext uri="{FF2B5EF4-FFF2-40B4-BE49-F238E27FC236}">
-                <a16:creationId xmlns:a16="http://schemas.microsoft.com/office/drawing/2014/main" id="{7B03F588-47D2-4FAA-AEBB-08EA74C57314}"/>
+                <a16:creationId xmlns:a16="http://schemas.microsoft.com/office/drawing/2014/main" id="{3F936674-2325-4AA4-99B6-D7CAE694FC49}"/>
               </a:ext>
             </a:extLst>
           </p:cNvPr>
@@ -5214,7 +5186,7 @@
     </p:spTree>
     <p:extLst>
       <p:ext uri="{BB962C8B-B14F-4D97-AF65-F5344CB8AC3E}">
-        <p14:creationId xmlns:p14="http://schemas.microsoft.com/office/powerpoint/2010/main" val="1778083888"/>
+        <p14:creationId xmlns:p14="http://schemas.microsoft.com/office/powerpoint/2010/main" val="1980151517"/>
       </p:ext>
     </p:extLst>
   </p:cSld>
@@ -5245,7 +5217,7 @@
           <p:cNvPr id="6" name="The first&#10;community pilot">
             <a:extLst xmlns:a="http://schemas.openxmlformats.org/drawingml/2006/main">
               <a:ext uri="{FF2B5EF4-FFF2-40B4-BE49-F238E27FC236}">
-                <a16:creationId xmlns:a16="http://schemas.microsoft.com/office/drawing/2014/main" id="{6251A9E7-4B4C-403B-82E1-5DD9C5C7191D}"/>
+                <a16:creationId xmlns:a16="http://schemas.microsoft.com/office/drawing/2014/main" id="{F5424F38-784C-4E7C-9763-052F0A0E6F6D}"/>
               </a:ext>
             </a:extLst>
           </p:cNvPr>
@@ -5325,7 +5297,7 @@
           <p:cNvPr id="2" name="A small trail of meaningful places.&#10;Original stickers f">
             <a:extLst xmlns:a="http://schemas.openxmlformats.org/drawingml/2006/main">
               <a:ext uri="{FF2B5EF4-FFF2-40B4-BE49-F238E27FC236}">
-                <a16:creationId xmlns:a16="http://schemas.microsoft.com/office/drawing/2014/main" id="{64AE01E9-247E-4162-877B-3B089ECD3166}"/>
+                <a16:creationId xmlns:a16="http://schemas.microsoft.com/office/drawing/2014/main" id="{C1A6CFFB-3D46-4490-B8B2-D05D8FC690EE}"/>
               </a:ext>
             </a:extLst>
           </p:cNvPr>
@@ -5428,7 +5400,7 @@
           <p:cNvPr id="3" name="Learn: do people finish, and return?">
             <a:extLst xmlns:a="http://schemas.openxmlformats.org/drawingml/2006/main">
               <a:ext uri="{FF2B5EF4-FFF2-40B4-BE49-F238E27FC236}">
-                <a16:creationId xmlns:a16="http://schemas.microsoft.com/office/drawing/2014/main" id="{3F505E17-E28A-4943-9FEF-23E10A881B46}"/>
+                <a16:creationId xmlns:a16="http://schemas.microsoft.com/office/drawing/2014/main" id="{CE4F8442-871E-4CFE-87AA-4EEFFCF30E74}"/>
               </a:ext>
             </a:extLst>
           </p:cNvPr>
@@ -5489,7 +5461,7 @@
           <p:nvPr/>
         </p:nvPicPr>
         <p:blipFill>
-          <a:blip xmlns:r="http://schemas.openxmlformats.org/officeDocument/2006/relationships" xmlns:a="http://schemas.openxmlformats.org/drawingml/2006/main" r:embed="Rd7363263997341bc"/>
+          <a:blip xmlns:r="http://schemas.openxmlformats.org/officeDocument/2006/relationships" xmlns:a="http://schemas.openxmlformats.org/drawingml/2006/main" r:embed="R816f38f94c974187"/>
           <a:stretch xmlns:a="http://schemas.openxmlformats.org/drawingml/2006/main"/>
         </p:blipFill>
         <p:spPr>
@@ -5507,7 +5479,7 @@
           <p:cNvPr id="5" name="08">
             <a:extLst xmlns:a="http://schemas.openxmlformats.org/drawingml/2006/main">
               <a:ext uri="{FF2B5EF4-FFF2-40B4-BE49-F238E27FC236}">
-                <a16:creationId xmlns:a16="http://schemas.microsoft.com/office/drawing/2014/main" id="{8F7D03B4-5160-4995-89F2-C2F37752C97A}"/>
+                <a16:creationId xmlns:a16="http://schemas.microsoft.com/office/drawing/2014/main" id="{A03A684B-7F90-4E51-AEFF-7AADC8E13EE2}"/>
               </a:ext>
             </a:extLst>
           </p:cNvPr>
@@ -5562,7 +5534,7 @@
     </p:spTree>
     <p:extLst>
       <p:ext uri="{BB962C8B-B14F-4D97-AF65-F5344CB8AC3E}">
-        <p14:creationId xmlns:p14="http://schemas.microsoft.com/office/powerpoint/2010/main" val="864066808"/>
+        <p14:creationId xmlns:p14="http://schemas.microsoft.com/office/powerpoint/2010/main" val="2027664844"/>
       </p:ext>
     </p:extLst>
   </p:cSld>
@@ -5593,7 +5565,7 @@
           <p:cNvPr id="6" name="Find your places.&#10;Collect your moments.">
             <a:extLst xmlns:a="http://schemas.openxmlformats.org/drawingml/2006/main">
               <a:ext uri="{FF2B5EF4-FFF2-40B4-BE49-F238E27FC236}">
-                <a16:creationId xmlns:a16="http://schemas.microsoft.com/office/drawing/2014/main" id="{769309C9-E603-4DA0-837F-71CEC7F7CAA2}"/>
+                <a16:creationId xmlns:a16="http://schemas.microsoft.com/office/drawing/2014/main" id="{682D0EF7-E994-4EEA-9600-24183738FA13}"/>
               </a:ext>
             </a:extLst>
           </p:cNvPr>
@@ -5673,7 +5645,7 @@
           <p:cNvPr id="2" name="Let’s create the first&#10;community trail together.">
             <a:extLst xmlns:a="http://schemas.openxmlformats.org/drawingml/2006/main">
               <a:ext uri="{FF2B5EF4-FFF2-40B4-BE49-F238E27FC236}">
-                <a16:creationId xmlns:a16="http://schemas.microsoft.com/office/drawing/2014/main" id="{ED2C1419-547F-4341-90AD-410D8A49943F}"/>
+                <a16:creationId xmlns:a16="http://schemas.microsoft.com/office/drawing/2014/main" id="{7DD0D7C0-7458-4B1F-AF96-C1891013EA21}"/>
               </a:ext>
             </a:extLst>
           </p:cNvPr>
@@ -5757,7 +5729,7 @@
           <p:nvPr/>
         </p:nvPicPr>
         <p:blipFill>
-          <a:blip xmlns:r="http://schemas.openxmlformats.org/officeDocument/2006/relationships" xmlns:a="http://schemas.openxmlformats.org/drawingml/2006/main" r:embed="R1ce18a1e50544b70"/>
+          <a:blip xmlns:r="http://schemas.openxmlformats.org/officeDocument/2006/relationships" xmlns:a="http://schemas.openxmlformats.org/drawingml/2006/main" r:embed="R3e8160c7f24b4925"/>
           <a:stretch xmlns:a="http://schemas.openxmlformats.org/drawingml/2006/main"/>
         </p:blipFill>
         <p:spPr>
@@ -5775,7 +5747,7 @@
           <p:cNvPr id="4" name="tagtag">
             <a:extLst xmlns:a="http://schemas.openxmlformats.org/drawingml/2006/main">
               <a:ext uri="{FF2B5EF4-FFF2-40B4-BE49-F238E27FC236}">
-                <a16:creationId xmlns:a16="http://schemas.microsoft.com/office/drawing/2014/main" id="{8030A47F-5C5D-4F14-BFF4-44C2DAC0A835}"/>
+                <a16:creationId xmlns:a16="http://schemas.microsoft.com/office/drawing/2014/main" id="{982D45C1-8A2E-45CD-BC65-EEF5084A77F4}"/>
               </a:ext>
             </a:extLst>
           </p:cNvPr>
@@ -5832,7 +5804,7 @@
           <p:cNvPr id="5" name="09">
             <a:extLst xmlns:a="http://schemas.openxmlformats.org/drawingml/2006/main">
               <a:ext uri="{FF2B5EF4-FFF2-40B4-BE49-F238E27FC236}">
-                <a16:creationId xmlns:a16="http://schemas.microsoft.com/office/drawing/2014/main" id="{7B10D589-2869-4588-A13E-C016EB7525A2}"/>
+                <a16:creationId xmlns:a16="http://schemas.microsoft.com/office/drawing/2014/main" id="{32A9A483-8EEB-441B-8F7C-D08BC2E4079A}"/>
               </a:ext>
             </a:extLst>
           </p:cNvPr>
@@ -5887,7 +5859,7 @@
     </p:spTree>
     <p:extLst>
       <p:ext uri="{BB962C8B-B14F-4D97-AF65-F5344CB8AC3E}">
-        <p14:creationId xmlns:p14="http://schemas.microsoft.com/office/powerpoint/2010/main" val="1099272759"/>
+        <p14:creationId xmlns:p14="http://schemas.microsoft.com/office/powerpoint/2010/main" val="769840966"/>
       </p:ext>
     </p:extLst>
   </p:cSld>

</xml_diff>

<commit_message>
docs: update opening slide tagline
</commit_message>
<xml_diff>
--- a/docs/submission/pitch/tagtag-pitch.pptx
+++ b/docs/submission/pitch/tagtag-pitch.pptx
@@ -2,21 +2,21 @@
 <file path=ppt/presentation.xml><?xml version="1.0" encoding="utf-8"?>
 <p:presentation xmlns:p="http://schemas.openxmlformats.org/presentationml/2006/main">
   <p:sldMasterIdLst>
-    <p:sldMasterId xmlns:r="http://schemas.openxmlformats.org/officeDocument/2006/relationships" id="2147483648" r:id="R658543d52aa249b8"/>
+    <p:sldMasterId xmlns:r="http://schemas.openxmlformats.org/officeDocument/2006/relationships" id="2147483648" r:id="R38d69f9edeaa4a06"/>
   </p:sldMasterIdLst>
   <p:notesMasterIdLst>
-    <p:notesMasterId xmlns:r="http://schemas.openxmlformats.org/officeDocument/2006/relationships" r:id="R4a857c09b4074ca2"/>
+    <p:notesMasterId xmlns:r="http://schemas.openxmlformats.org/officeDocument/2006/relationships" r:id="R65f4ec0818a3488a"/>
   </p:notesMasterIdLst>
   <p:sldIdLst>
-    <p:sldId xmlns:r="http://schemas.openxmlformats.org/officeDocument/2006/relationships" id="256" r:id="Rd6a90e22309f4966"/>
-    <p:sldId xmlns:r="http://schemas.openxmlformats.org/officeDocument/2006/relationships" id="257" r:id="R9e5c6544bce84255"/>
-    <p:sldId xmlns:r="http://schemas.openxmlformats.org/officeDocument/2006/relationships" id="258" r:id="R88cf291412884391"/>
-    <p:sldId xmlns:r="http://schemas.openxmlformats.org/officeDocument/2006/relationships" id="259" r:id="Ra63fbea262d94d5f"/>
-    <p:sldId xmlns:r="http://schemas.openxmlformats.org/officeDocument/2006/relationships" id="260" r:id="R5874a79e82f04196"/>
-    <p:sldId xmlns:r="http://schemas.openxmlformats.org/officeDocument/2006/relationships" id="261" r:id="Rf55e761eaeb84ee2"/>
-    <p:sldId xmlns:r="http://schemas.openxmlformats.org/officeDocument/2006/relationships" id="262" r:id="Reae7bf379ab64abf"/>
-    <p:sldId xmlns:r="http://schemas.openxmlformats.org/officeDocument/2006/relationships" id="263" r:id="Rd34f8fc34ac94555"/>
-    <p:sldId xmlns:r="http://schemas.openxmlformats.org/officeDocument/2006/relationships" id="264" r:id="Rb52dddecc23b4468"/>
+    <p:sldId xmlns:r="http://schemas.openxmlformats.org/officeDocument/2006/relationships" id="256" r:id="R35c321e3a7e54932"/>
+    <p:sldId xmlns:r="http://schemas.openxmlformats.org/officeDocument/2006/relationships" id="257" r:id="R603bacd3b8ac4c80"/>
+    <p:sldId xmlns:r="http://schemas.openxmlformats.org/officeDocument/2006/relationships" id="258" r:id="R74ae433359bd4be7"/>
+    <p:sldId xmlns:r="http://schemas.openxmlformats.org/officeDocument/2006/relationships" id="259" r:id="R702d6a231bde4851"/>
+    <p:sldId xmlns:r="http://schemas.openxmlformats.org/officeDocument/2006/relationships" id="260" r:id="R077217c3f93c4588"/>
+    <p:sldId xmlns:r="http://schemas.openxmlformats.org/officeDocument/2006/relationships" id="261" r:id="Rf4fc5ba1d7354978"/>
+    <p:sldId xmlns:r="http://schemas.openxmlformats.org/officeDocument/2006/relationships" id="262" r:id="Rf54c86c581474887"/>
+    <p:sldId xmlns:r="http://schemas.openxmlformats.org/officeDocument/2006/relationships" id="263" r:id="R3336b9008e0948a1"/>
+    <p:sldId xmlns:r="http://schemas.openxmlformats.org/officeDocument/2006/relationships" id="264" r:id="R0e253a46fb5246a0"/>
   </p:sldIdLst>
   <p:sldSz cx="12192000" cy="6858000"/>
   <p:notesSz cx="6858000" cy="9144000"/>
@@ -460,7 +460,7 @@
           </a:p>
           <a:p xmlns:a="http://schemas.openxmlformats.org/drawingml/2006/main">
             <a:r>
-              <a:t>“What if your favourite places had something waiting for you? tagtag is an augmented reality collecting game that helps communities create discoveries worth sharing. Find your places. Collect your moments.”</a:t>
+              <a:t>“What if your favourite places had something waiting for you? tagtag is an augmented reality collecting game that helps communities create discoveries worth sharing. Find new places. Collect your moments.”</a:t>
             </a:r>
           </a:p>
           <a:p xmlns:a="http://schemas.openxmlformats.org/drawingml/2006/main">
@@ -1295,7 +1295,7 @@
           <a:lstStyle xmlns:a="http://schemas.openxmlformats.org/drawingml/2006/main"/>
           <a:p xmlns:a="http://schemas.openxmlformats.org/drawingml/2006/main">
             <a:r>
-              <a:t>3:50–4:00 · Slide 9 · Find your places. Collect your moments.</a:t>
+              <a:t>3:50–4:00 · Slide 9 · Find your places. Collect your moments</a:t>
             </a:r>
           </a:p>
           <a:p xmlns:a="http://schemas.openxmlformats.org/drawingml/2006/main">
@@ -1448,7 +1448,7 @@
   </p:cSld>
   <p:clrMap bg1="lt1" tx1="dk1" bg2="lt2" tx2="dk2" accent1="accent1" accent2="accent2" accent3="accent3" accent4="accent4" accent5="accent5" accent6="accent6" hlink="hlink" folHlink="folHlink"/>
   <p:sldLayoutIdLst>
-    <p:sldLayoutId xmlns:r="http://schemas.openxmlformats.org/officeDocument/2006/relationships" id="2147483649" r:id="R4b97dbdfd3174a1e"/>
+    <p:sldLayoutId xmlns:r="http://schemas.openxmlformats.org/officeDocument/2006/relationships" id="2147483649" r:id="Rb41c1b82dbf149f4"/>
   </p:sldLayoutIdLst>
   <p:txStyles>
     <p:titleStyle>
@@ -1999,7 +1999,7 @@
           <p:cNvPr id="7" name="tagtag">
             <a:extLst xmlns:a="http://schemas.openxmlformats.org/drawingml/2006/main">
               <a:ext uri="{FF2B5EF4-FFF2-40B4-BE49-F238E27FC236}">
-                <a16:creationId xmlns:a16="http://schemas.microsoft.com/office/drawing/2014/main" id="{8A3D3325-D22E-49ED-A209-318EDB917A6B}"/>
+                <a16:creationId xmlns:a16="http://schemas.microsoft.com/office/drawing/2014/main" id="{B265EEDE-2472-4BD1-8AF3-0A3F7609B133}"/>
               </a:ext>
             </a:extLst>
           </p:cNvPr>
@@ -2056,7 +2056,7 @@
           <p:cNvPr id="2" name="An AR collecting game&#10;for communities">
             <a:extLst xmlns:a="http://schemas.openxmlformats.org/drawingml/2006/main">
               <a:ext uri="{FF2B5EF4-FFF2-40B4-BE49-F238E27FC236}">
-                <a16:creationId xmlns:a16="http://schemas.microsoft.com/office/drawing/2014/main" id="{6F643B0B-1CC9-4448-8EBB-483FBD5128A2}"/>
+                <a16:creationId xmlns:a16="http://schemas.microsoft.com/office/drawing/2014/main" id="{F4721F0F-36B1-4D25-8FAF-56308F0F73BA}"/>
               </a:ext>
             </a:extLst>
           </p:cNvPr>
@@ -2133,10 +2133,10 @@
       </p:sp>
       <p:sp>
         <p:nvSpPr>
-          <p:cNvPr id="3" name="Find your places. Collect your moments.">
+          <p:cNvPr id="3" name="Find new places. Collect your moments">
             <a:extLst xmlns:a="http://schemas.openxmlformats.org/drawingml/2006/main">
               <a:ext uri="{FF2B5EF4-FFF2-40B4-BE49-F238E27FC236}">
-                <a16:creationId xmlns:a16="http://schemas.microsoft.com/office/drawing/2014/main" id="{8A36AD42-0155-4D98-97A9-EA31FC4D4B26}"/>
+                <a16:creationId xmlns:a16="http://schemas.microsoft.com/office/drawing/2014/main" id="{52E10A72-F491-4D35-9F9E-BCC4C2F20F3D}"/>
               </a:ext>
             </a:extLst>
           </p:cNvPr>
@@ -2183,7 +2183,7 @@
                 <a:ea typeface="Shadows Into Light"/>
                 <a:cs typeface="Shadows Into Light"/>
               </a:rPr>
-              <a:t>Find your places. Collect your moments.</a:t>
+              <a:t>Find new places. Collect your moments</a:t>
             </a:r>
           </a:p>
         </p:txBody>
@@ -2197,7 +2197,7 @@
           <p:nvPr/>
         </p:nvPicPr>
         <p:blipFill>
-          <a:blip xmlns:r="http://schemas.openxmlformats.org/officeDocument/2006/relationships" xmlns:a="http://schemas.openxmlformats.org/drawingml/2006/main" r:embed="Rde51e5a14472491d"/>
+          <a:blip xmlns:r="http://schemas.openxmlformats.org/officeDocument/2006/relationships" xmlns:a="http://schemas.openxmlformats.org/drawingml/2006/main" r:embed="Red37c314f9154145"/>
           <a:stretch xmlns:a="http://schemas.openxmlformats.org/drawingml/2006/main"/>
         </p:blipFill>
         <p:spPr>
@@ -2215,7 +2215,7 @@
           <p:cNvPr id="5" name="ETHGlobal Tokyo 2026">
             <a:extLst xmlns:a="http://schemas.openxmlformats.org/drawingml/2006/main">
               <a:ext uri="{FF2B5EF4-FFF2-40B4-BE49-F238E27FC236}">
-                <a16:creationId xmlns:a16="http://schemas.microsoft.com/office/drawing/2014/main" id="{41D4FB68-4AA4-4827-8349-4BDBAD112562}"/>
+                <a16:creationId xmlns:a16="http://schemas.microsoft.com/office/drawing/2014/main" id="{6558B119-7BB1-4410-BE6C-03D6067145E9}"/>
               </a:ext>
             </a:extLst>
           </p:cNvPr>
@@ -2272,7 +2272,7 @@
           <p:cNvPr id="6" name="01">
             <a:extLst xmlns:a="http://schemas.openxmlformats.org/drawingml/2006/main">
               <a:ext uri="{FF2B5EF4-FFF2-40B4-BE49-F238E27FC236}">
-                <a16:creationId xmlns:a16="http://schemas.microsoft.com/office/drawing/2014/main" id="{60F8286C-CF2E-4EFD-88F9-25BAD5317E94}"/>
+                <a16:creationId xmlns:a16="http://schemas.microsoft.com/office/drawing/2014/main" id="{460D2B6F-0A9B-4E62-AF41-65F36AC89793}"/>
               </a:ext>
             </a:extLst>
           </p:cNvPr>
@@ -2327,7 +2327,7 @@
     </p:spTree>
     <p:extLst>
       <p:ext uri="{BB962C8B-B14F-4D97-AF65-F5344CB8AC3E}">
-        <p14:creationId xmlns:p14="http://schemas.microsoft.com/office/powerpoint/2010/main" val="1845626591"/>
+        <p14:creationId xmlns:p14="http://schemas.microsoft.com/office/powerpoint/2010/main" val="21295079"/>
       </p:ext>
     </p:extLst>
   </p:cSld>
@@ -2358,7 +2358,7 @@
           <p:cNvPr id="12" name="Two inspirations">
             <a:extLst xmlns:a="http://schemas.openxmlformats.org/drawingml/2006/main">
               <a:ext uri="{FF2B5EF4-FFF2-40B4-BE49-F238E27FC236}">
-                <a16:creationId xmlns:a16="http://schemas.microsoft.com/office/drawing/2014/main" id="{3475C595-E530-4027-AF4E-47F3FB408653}"/>
+                <a16:creationId xmlns:a16="http://schemas.microsoft.com/office/drawing/2014/main" id="{BEE04054-396F-49B6-B529-8F0053256000}"/>
               </a:ext>
             </a:extLst>
           </p:cNvPr>
@@ -2415,7 +2415,7 @@
           <p:cNvPr id="2" name="POAP">
             <a:extLst xmlns:a="http://schemas.openxmlformats.org/drawingml/2006/main">
               <a:ext uri="{FF2B5EF4-FFF2-40B4-BE49-F238E27FC236}">
-                <a16:creationId xmlns:a16="http://schemas.microsoft.com/office/drawing/2014/main" id="{66D1F7A7-74E6-4CB4-B026-14D19FE93BBA}"/>
+                <a16:creationId xmlns:a16="http://schemas.microsoft.com/office/drawing/2014/main" id="{BCDC3154-5CF3-4B97-90D0-806B7C78E8DD}"/>
               </a:ext>
             </a:extLst>
           </p:cNvPr>
@@ -2472,7 +2472,7 @@
           <p:cNvPr id="3" name="Memories worth keeping">
             <a:extLst xmlns:a="http://schemas.openxmlformats.org/drawingml/2006/main">
               <a:ext uri="{FF2B5EF4-FFF2-40B4-BE49-F238E27FC236}">
-                <a16:creationId xmlns:a16="http://schemas.microsoft.com/office/drawing/2014/main" id="{0190187C-DCA8-4033-B4ED-DCD0D7CC984D}"/>
+                <a16:creationId xmlns:a16="http://schemas.microsoft.com/office/drawing/2014/main" id="{248A5AF2-B7D2-4F94-B267-E8068629EF46}"/>
               </a:ext>
             </a:extLst>
           </p:cNvPr>
@@ -2529,7 +2529,7 @@
           <p:cNvPr id="4" name="~7.6 million">
             <a:extLst xmlns:a="http://schemas.openxmlformats.org/drawingml/2006/main">
               <a:ext uri="{FF2B5EF4-FFF2-40B4-BE49-F238E27FC236}">
-                <a16:creationId xmlns:a16="http://schemas.microsoft.com/office/drawing/2014/main" id="{3FAEA1A8-4EB6-4444-9CE1-EB2D0BEB4944}"/>
+                <a16:creationId xmlns:a16="http://schemas.microsoft.com/office/drawing/2014/main" id="{A1A7ECBB-9DEF-4035-80FF-10E8616BDBD9}"/>
               </a:ext>
             </a:extLst>
           </p:cNvPr>
@@ -2586,7 +2586,7 @@
           <p:cNvPr id="5" name="badges minted">
             <a:extLst xmlns:a="http://schemas.openxmlformats.org/drawingml/2006/main">
               <a:ext uri="{FF2B5EF4-FFF2-40B4-BE49-F238E27FC236}">
-                <a16:creationId xmlns:a16="http://schemas.microsoft.com/office/drawing/2014/main" id="{053A32F6-80D6-4C46-832A-DF5E90CBC6F1}"/>
+                <a16:creationId xmlns:a16="http://schemas.microsoft.com/office/drawing/2014/main" id="{913A7C61-86F1-41B0-9422-58C74D41B587}"/>
               </a:ext>
             </a:extLst>
           </p:cNvPr>
@@ -2643,7 +2643,7 @@
           <p:cNvPr id="6" name="46,210+ issuers">
             <a:extLst xmlns:a="http://schemas.openxmlformats.org/drawingml/2006/main">
               <a:ext uri="{FF2B5EF4-FFF2-40B4-BE49-F238E27FC236}">
-                <a16:creationId xmlns:a16="http://schemas.microsoft.com/office/drawing/2014/main" id="{D831787F-9012-497B-8180-822661E7C5FE}"/>
+                <a16:creationId xmlns:a16="http://schemas.microsoft.com/office/drawing/2014/main" id="{B62F11BD-EBBF-4735-8462-34FAFD7B4144}"/>
               </a:ext>
             </a:extLst>
           </p:cNvPr>
@@ -2700,7 +2700,7 @@
           <p:cNvPr id="7" name="Pokémon GO">
             <a:extLst xmlns:a="http://schemas.openxmlformats.org/drawingml/2006/main">
               <a:ext uri="{FF2B5EF4-FFF2-40B4-BE49-F238E27FC236}">
-                <a16:creationId xmlns:a16="http://schemas.microsoft.com/office/drawing/2014/main" id="{F4E95E89-BFCC-4B67-A22D-73272CD63927}"/>
+                <a16:creationId xmlns:a16="http://schemas.microsoft.com/office/drawing/2014/main" id="{5FF8E7DD-4E53-40C3-8769-0AEADE8B16FD}"/>
               </a:ext>
             </a:extLst>
           </p:cNvPr>
@@ -2757,7 +2757,7 @@
           <p:cNvPr id="8" name="Discovery worth&#10;going out for">
             <a:extLst xmlns:a="http://schemas.openxmlformats.org/drawingml/2006/main">
               <a:ext uri="{FF2B5EF4-FFF2-40B4-BE49-F238E27FC236}">
-                <a16:creationId xmlns:a16="http://schemas.microsoft.com/office/drawing/2014/main" id="{1A6C2F16-E9D3-4073-9D0C-821291A315EF}"/>
+                <a16:creationId xmlns:a16="http://schemas.microsoft.com/office/drawing/2014/main" id="{93633190-66A6-4DCF-B9DA-E46F61CEB9A4}"/>
               </a:ext>
             </a:extLst>
           </p:cNvPr>
@@ -2841,7 +2841,7 @@
           <p:nvPr/>
         </p:nvPicPr>
         <p:blipFill>
-          <a:blip xmlns:r="http://schemas.openxmlformats.org/officeDocument/2006/relationships" xmlns:a="http://schemas.openxmlformats.org/drawingml/2006/main" r:embed="R5b5dfd2e99c740f4"/>
+          <a:blip xmlns:r="http://schemas.openxmlformats.org/officeDocument/2006/relationships" xmlns:a="http://schemas.openxmlformats.org/drawingml/2006/main" r:embed="R97918b239304439d"/>
           <a:stretch xmlns:a="http://schemas.openxmlformats.org/drawingml/2006/main"/>
         </p:blipFill>
         <p:spPr>
@@ -2859,7 +2859,7 @@
           <p:cNvPr id="10" name="Historical totals reported August 2026">
             <a:extLst xmlns:a="http://schemas.openxmlformats.org/drawingml/2006/main">
               <a:ext uri="{FF2B5EF4-FFF2-40B4-BE49-F238E27FC236}">
-                <a16:creationId xmlns:a16="http://schemas.microsoft.com/office/drawing/2014/main" id="{FDC549A6-06F3-49B5-A9CE-78E6845A6F54}"/>
+                <a16:creationId xmlns:a16="http://schemas.microsoft.com/office/drawing/2014/main" id="{0F48F550-986A-42F5-87B0-73EB0FFFD0B5}"/>
               </a:ext>
             </a:extLst>
           </p:cNvPr>
@@ -2916,7 +2916,7 @@
           <p:cNvPr id="11" name="02">
             <a:extLst xmlns:a="http://schemas.openxmlformats.org/drawingml/2006/main">
               <a:ext uri="{FF2B5EF4-FFF2-40B4-BE49-F238E27FC236}">
-                <a16:creationId xmlns:a16="http://schemas.microsoft.com/office/drawing/2014/main" id="{7EB6811F-05DB-46AD-84DC-47E9D872ADD2}"/>
+                <a16:creationId xmlns:a16="http://schemas.microsoft.com/office/drawing/2014/main" id="{7046FFFA-AFC4-49B0-B7DF-A3E644C81B1E}"/>
               </a:ext>
             </a:extLst>
           </p:cNvPr>
@@ -2971,7 +2971,7 @@
     </p:spTree>
     <p:extLst>
       <p:ext uri="{BB962C8B-B14F-4D97-AF65-F5344CB8AC3E}">
-        <p14:creationId xmlns:p14="http://schemas.microsoft.com/office/powerpoint/2010/main" val="330907506"/>
+        <p14:creationId xmlns:p14="http://schemas.microsoft.com/office/powerpoint/2010/main" val="1798326526"/>
       </p:ext>
     </p:extLst>
   </p:cSld>
@@ -3006,7 +3006,7 @@
           <p:nvPr/>
         </p:nvPicPr>
         <p:blipFill>
-          <a:blip xmlns:r="http://schemas.openxmlformats.org/officeDocument/2006/relationships" xmlns:a="http://schemas.openxmlformats.org/drawingml/2006/main" r:embed="Rec758affe4034f3d"/>
+          <a:blip xmlns:r="http://schemas.openxmlformats.org/officeDocument/2006/relationships" xmlns:a="http://schemas.openxmlformats.org/drawingml/2006/main" r:embed="R3e77c26f9bdd4d6d"/>
           <a:stretch xmlns:a="http://schemas.openxmlformats.org/drawingml/2006/main"/>
         </p:blipFill>
         <p:spPr>
@@ -3024,7 +3024,7 @@
           <p:cNvPr id="2" name="A place has&#10;a story">
             <a:extLst xmlns:a="http://schemas.openxmlformats.org/drawingml/2006/main">
               <a:ext uri="{FF2B5EF4-FFF2-40B4-BE49-F238E27FC236}">
-                <a16:creationId xmlns:a16="http://schemas.microsoft.com/office/drawing/2014/main" id="{A5EEA3CE-1DF0-40CF-ACBF-4F72966E44D3}"/>
+                <a16:creationId xmlns:a16="http://schemas.microsoft.com/office/drawing/2014/main" id="{C919D032-308E-46E4-A7AA-7299AFF7410E}"/>
               </a:ext>
             </a:extLst>
           </p:cNvPr>
@@ -3104,7 +3104,7 @@
           <p:cNvPr id="3" name="Leave a little discovery&#10;for the next person.">
             <a:extLst xmlns:a="http://schemas.openxmlformats.org/drawingml/2006/main">
               <a:ext uri="{FF2B5EF4-FFF2-40B4-BE49-F238E27FC236}">
-                <a16:creationId xmlns:a16="http://schemas.microsoft.com/office/drawing/2014/main" id="{25043FFF-6303-43BC-9134-1B820CC3B39F}"/>
+                <a16:creationId xmlns:a16="http://schemas.microsoft.com/office/drawing/2014/main" id="{7450293D-EF29-40B2-A312-7A6627188248}"/>
               </a:ext>
             </a:extLst>
           </p:cNvPr>
@@ -3184,7 +3184,7 @@
           <p:cNvPr id="4" name="App preview from iOS Simulator">
             <a:extLst xmlns:a="http://schemas.openxmlformats.org/drawingml/2006/main">
               <a:ext uri="{FF2B5EF4-FFF2-40B4-BE49-F238E27FC236}">
-                <a16:creationId xmlns:a16="http://schemas.microsoft.com/office/drawing/2014/main" id="{397D6B5C-CD10-4F1E-A4CF-1CC8C73AA7AC}"/>
+                <a16:creationId xmlns:a16="http://schemas.microsoft.com/office/drawing/2014/main" id="{1BD34850-ACEF-496B-B393-3D3F80EA7940}"/>
               </a:ext>
             </a:extLst>
           </p:cNvPr>
@@ -3241,7 +3241,7 @@
           <p:cNvPr id="5" name="03">
             <a:extLst xmlns:a="http://schemas.openxmlformats.org/drawingml/2006/main">
               <a:ext uri="{FF2B5EF4-FFF2-40B4-BE49-F238E27FC236}">
-                <a16:creationId xmlns:a16="http://schemas.microsoft.com/office/drawing/2014/main" id="{A359F2B9-1D35-4356-8E03-A303A53682BE}"/>
+                <a16:creationId xmlns:a16="http://schemas.microsoft.com/office/drawing/2014/main" id="{27245585-C5BE-4A67-849D-43AEB4580401}"/>
               </a:ext>
             </a:extLst>
           </p:cNvPr>
@@ -3296,7 +3296,7 @@
     </p:spTree>
     <p:extLst>
       <p:ext uri="{BB962C8B-B14F-4D97-AF65-F5344CB8AC3E}">
-        <p14:creationId xmlns:p14="http://schemas.microsoft.com/office/powerpoint/2010/main" val="2075273739"/>
+        <p14:creationId xmlns:p14="http://schemas.microsoft.com/office/powerpoint/2010/main" val="427304421"/>
       </p:ext>
     </p:extLst>
   </p:cSld>
@@ -3327,7 +3327,7 @@
           <p:cNvPr id="12" name="The collecting loop">
             <a:extLst xmlns:a="http://schemas.openxmlformats.org/drawingml/2006/main">
               <a:ext uri="{FF2B5EF4-FFF2-40B4-BE49-F238E27FC236}">
-                <a16:creationId xmlns:a16="http://schemas.microsoft.com/office/drawing/2014/main" id="{3AC9FB92-7432-4A78-97A3-B9B81402005B}"/>
+                <a16:creationId xmlns:a16="http://schemas.microsoft.com/office/drawing/2014/main" id="{5C7D8944-6FE9-4D13-A391-EF18D72F3BB5}"/>
               </a:ext>
             </a:extLst>
           </p:cNvPr>
@@ -3388,7 +3388,7 @@
           <p:nvPr/>
         </p:nvPicPr>
         <p:blipFill>
-          <a:blip xmlns:r="http://schemas.openxmlformats.org/officeDocument/2006/relationships" xmlns:a="http://schemas.openxmlformats.org/drawingml/2006/main" r:embed="R32a42fb0ff2942b4"/>
+          <a:blip xmlns:r="http://schemas.openxmlformats.org/officeDocument/2006/relationships" xmlns:a="http://schemas.openxmlformats.org/drawingml/2006/main" r:embed="R0c29938816dc4fc2"/>
           <a:stretch xmlns:a="http://schemas.openxmlformats.org/drawingml/2006/main"/>
         </p:blipFill>
         <p:spPr>
@@ -3410,7 +3410,7 @@
           <p:nvPr/>
         </p:nvPicPr>
         <p:blipFill>
-          <a:blip xmlns:r="http://schemas.openxmlformats.org/officeDocument/2006/relationships" xmlns:a="http://schemas.openxmlformats.org/drawingml/2006/main" r:embed="R726c12754c7b4fc0"/>
+          <a:blip xmlns:r="http://schemas.openxmlformats.org/officeDocument/2006/relationships" xmlns:a="http://schemas.openxmlformats.org/drawingml/2006/main" r:embed="Rbd97362787d9428e"/>
           <a:stretch xmlns:a="http://schemas.openxmlformats.org/drawingml/2006/main"/>
         </p:blipFill>
         <p:spPr>
@@ -3432,7 +3432,7 @@
           <p:nvPr/>
         </p:nvPicPr>
         <p:blipFill>
-          <a:blip xmlns:r="http://schemas.openxmlformats.org/officeDocument/2006/relationships" xmlns:a="http://schemas.openxmlformats.org/drawingml/2006/main" r:embed="R3e5ba97cadab4b3e"/>
+          <a:blip xmlns:r="http://schemas.openxmlformats.org/officeDocument/2006/relationships" xmlns:a="http://schemas.openxmlformats.org/drawingml/2006/main" r:embed="Rf71839c5f2ef4c0b"/>
           <a:stretch xmlns:a="http://schemas.openxmlformats.org/drawingml/2006/main"/>
         </p:blipFill>
         <p:spPr>
@@ -3450,7 +3450,7 @@
           <p:cNvPr id="5" name="1. Leave a sticker">
             <a:extLst xmlns:a="http://schemas.openxmlformats.org/drawingml/2006/main">
               <a:ext uri="{FF2B5EF4-FFF2-40B4-BE49-F238E27FC236}">
-                <a16:creationId xmlns:a16="http://schemas.microsoft.com/office/drawing/2014/main" id="{A6BF35EA-E871-425C-9F56-D4C73BF0A8D9}"/>
+                <a16:creationId xmlns:a16="http://schemas.microsoft.com/office/drawing/2014/main" id="{60CEAB00-3830-45DD-90C8-6D1685A71680}"/>
               </a:ext>
             </a:extLst>
           </p:cNvPr>
@@ -3507,7 +3507,7 @@
           <p:cNvPr id="6" name="Art, a place, a private note.">
             <a:extLst xmlns:a="http://schemas.openxmlformats.org/drawingml/2006/main">
               <a:ext uri="{FF2B5EF4-FFF2-40B4-BE49-F238E27FC236}">
-                <a16:creationId xmlns:a16="http://schemas.microsoft.com/office/drawing/2014/main" id="{A2723D09-456B-40E8-93F4-5C9B0D4AA82B}"/>
+                <a16:creationId xmlns:a16="http://schemas.microsoft.com/office/drawing/2014/main" id="{00192C53-E138-4800-8B15-0DDE0151CB75}"/>
               </a:ext>
             </a:extLst>
           </p:cNvPr>
@@ -3564,7 +3564,7 @@
           <p:cNvPr id="7" name="2. Find its place">
             <a:extLst xmlns:a="http://schemas.openxmlformats.org/drawingml/2006/main">
               <a:ext uri="{FF2B5EF4-FFF2-40B4-BE49-F238E27FC236}">
-                <a16:creationId xmlns:a16="http://schemas.microsoft.com/office/drawing/2014/main" id="{CDE1451D-604E-49B2-843A-F15259184D37}"/>
+                <a16:creationId xmlns:a16="http://schemas.microsoft.com/office/drawing/2014/main" id="{19A77F70-A59F-477F-91A7-73F8D41513D3}"/>
               </a:ext>
             </a:extLst>
           </p:cNvPr>
@@ -3621,7 +3621,7 @@
           <p:cNvPr id="8" name="Follow the clue into AR.">
             <a:extLst xmlns:a="http://schemas.openxmlformats.org/drawingml/2006/main">
               <a:ext uri="{FF2B5EF4-FFF2-40B4-BE49-F238E27FC236}">
-                <a16:creationId xmlns:a16="http://schemas.microsoft.com/office/drawing/2014/main" id="{3E8B6DE3-FEB6-4903-953E-C38424CA579A}"/>
+                <a16:creationId xmlns:a16="http://schemas.microsoft.com/office/drawing/2014/main" id="{FDDE9F01-E091-4D72-B683-64FCB638FE39}"/>
               </a:ext>
             </a:extLst>
           </p:cNvPr>
@@ -3678,7 +3678,7 @@
           <p:cNvPr id="9" name="3. Keep the memory">
             <a:extLst xmlns:a="http://schemas.openxmlformats.org/drawingml/2006/main">
               <a:ext uri="{FF2B5EF4-FFF2-40B4-BE49-F238E27FC236}">
-                <a16:creationId xmlns:a16="http://schemas.microsoft.com/office/drawing/2014/main" id="{FDA0BFE9-FBB0-4C2E-811E-732C010B13C2}"/>
+                <a16:creationId xmlns:a16="http://schemas.microsoft.com/office/drawing/2014/main" id="{8326014A-D33F-4D7B-BA68-76F41B17400E}"/>
               </a:ext>
             </a:extLst>
           </p:cNvPr>
@@ -3735,7 +3735,7 @@
           <p:cNvPr id="10" name="Collect a copy. Reveal the note.">
             <a:extLst xmlns:a="http://schemas.openxmlformats.org/drawingml/2006/main">
               <a:ext uri="{FF2B5EF4-FFF2-40B4-BE49-F238E27FC236}">
-                <a16:creationId xmlns:a16="http://schemas.microsoft.com/office/drawing/2014/main" id="{2D84635F-B701-4640-B472-94C341770CE7}"/>
+                <a16:creationId xmlns:a16="http://schemas.microsoft.com/office/drawing/2014/main" id="{31D27B99-23FB-42C2-9FE4-BF585115C470}"/>
               </a:ext>
             </a:extLst>
           </p:cNvPr>
@@ -3792,7 +3792,7 @@
           <p:cNvPr id="11" name="04">
             <a:extLst xmlns:a="http://schemas.openxmlformats.org/drawingml/2006/main">
               <a:ext uri="{FF2B5EF4-FFF2-40B4-BE49-F238E27FC236}">
-                <a16:creationId xmlns:a16="http://schemas.microsoft.com/office/drawing/2014/main" id="{790F6DB7-EA53-411E-AD68-719932D6DB62}"/>
+                <a16:creationId xmlns:a16="http://schemas.microsoft.com/office/drawing/2014/main" id="{A6EE8A9A-9053-4E29-81FF-0D117A4F2857}"/>
               </a:ext>
             </a:extLst>
           </p:cNvPr>
@@ -3847,7 +3847,7 @@
     </p:spTree>
     <p:extLst>
       <p:ext uri="{BB962C8B-B14F-4D97-AF65-F5344CB8AC3E}">
-        <p14:creationId xmlns:p14="http://schemas.microsoft.com/office/powerpoint/2010/main" val="6549200"/>
+        <p14:creationId xmlns:p14="http://schemas.microsoft.com/office/powerpoint/2010/main" val="1339768186"/>
       </p:ext>
     </p:extLst>
   </p:cSld>
@@ -3878,7 +3878,7 @@
           <p:cNvPr id="9" name="A game communities&#10;can make their own">
             <a:extLst xmlns:a="http://schemas.openxmlformats.org/drawingml/2006/main">
               <a:ext uri="{FF2B5EF4-FFF2-40B4-BE49-F238E27FC236}">
-                <a16:creationId xmlns:a16="http://schemas.microsoft.com/office/drawing/2014/main" id="{2A0F6FD0-EEA9-4801-BFAA-A4546F3D6C66}"/>
+                <a16:creationId xmlns:a16="http://schemas.microsoft.com/office/drawing/2014/main" id="{EEDC5D0B-CB00-4223-8445-D69D4E0D3ECF}"/>
               </a:ext>
             </a:extLst>
           </p:cNvPr>
@@ -3958,7 +3958,7 @@
           <p:cNvPr id="2" name="A conference’s gathering places">
             <a:extLst xmlns:a="http://schemas.openxmlformats.org/drawingml/2006/main">
               <a:ext uri="{FF2B5EF4-FFF2-40B4-BE49-F238E27FC236}">
-                <a16:creationId xmlns:a16="http://schemas.microsoft.com/office/drawing/2014/main" id="{6399642F-AA79-437C-9258-83B41F6A4308}"/>
+                <a16:creationId xmlns:a16="http://schemas.microsoft.com/office/drawing/2014/main" id="{B80F441D-AB7F-4AFC-968E-5052AA53BE36}"/>
               </a:ext>
             </a:extLst>
           </p:cNvPr>
@@ -4015,7 +4015,7 @@
           <p:cNvPr id="3" name="A neighbourhood’s art walk">
             <a:extLst xmlns:a="http://schemas.openxmlformats.org/drawingml/2006/main">
               <a:ext uri="{FF2B5EF4-FFF2-40B4-BE49-F238E27FC236}">
-                <a16:creationId xmlns:a16="http://schemas.microsoft.com/office/drawing/2014/main" id="{D71982D1-1D36-400F-A745-88B980F8ADD6}"/>
+                <a16:creationId xmlns:a16="http://schemas.microsoft.com/office/drawing/2014/main" id="{990062D2-C1CA-4CA5-80AD-32C6F8742226}"/>
               </a:ext>
             </a:extLst>
           </p:cNvPr>
@@ -4072,7 +4072,7 @@
           <p:cNvPr id="4" name="Shared discoveries give people&#10;a reason to meet and ret">
             <a:extLst xmlns:a="http://schemas.openxmlformats.org/drawingml/2006/main">
               <a:ext uri="{FF2B5EF4-FFF2-40B4-BE49-F238E27FC236}">
-                <a16:creationId xmlns:a16="http://schemas.microsoft.com/office/drawing/2014/main" id="{C8B20467-2CAC-4A10-A229-A7A050215338}"/>
+                <a16:creationId xmlns:a16="http://schemas.microsoft.com/office/drawing/2014/main" id="{5DBB5FE5-E433-433E-BBA5-1359D13BF6A3}"/>
               </a:ext>
             </a:extLst>
           </p:cNvPr>
@@ -4156,7 +4156,7 @@
           <p:nvPr/>
         </p:nvPicPr>
         <p:blipFill>
-          <a:blip xmlns:r="http://schemas.openxmlformats.org/officeDocument/2006/relationships" xmlns:a="http://schemas.openxmlformats.org/drawingml/2006/main" r:embed="Rc38da9b3b10942b1"/>
+          <a:blip xmlns:r="http://schemas.openxmlformats.org/officeDocument/2006/relationships" xmlns:a="http://schemas.openxmlformats.org/drawingml/2006/main" r:embed="Ra977a76cea164b80"/>
           <a:stretch xmlns:a="http://schemas.openxmlformats.org/drawingml/2006/main"/>
         </p:blipFill>
         <p:spPr>
@@ -4174,7 +4174,7 @@
           <p:cNvPr id="6" name="Proposed uses">
             <a:extLst xmlns:a="http://schemas.openxmlformats.org/drawingml/2006/main">
               <a:ext uri="{FF2B5EF4-FFF2-40B4-BE49-F238E27FC236}">
-                <a16:creationId xmlns:a16="http://schemas.microsoft.com/office/drawing/2014/main" id="{746F4926-5B54-466D-8342-5EBDD1C54DCF}"/>
+                <a16:creationId xmlns:a16="http://schemas.microsoft.com/office/drawing/2014/main" id="{6AFA089C-249D-4C57-B5DB-6E5529AFE4E2}"/>
               </a:ext>
             </a:extLst>
           </p:cNvPr>
@@ -4231,7 +4231,7 @@
           <p:cNvPr id="7" name="UI preview / sample data">
             <a:extLst xmlns:a="http://schemas.openxmlformats.org/drawingml/2006/main">
               <a:ext uri="{FF2B5EF4-FFF2-40B4-BE49-F238E27FC236}">
-                <a16:creationId xmlns:a16="http://schemas.microsoft.com/office/drawing/2014/main" id="{E8221F4F-F525-4CCD-8218-B20CC99A9A3E}"/>
+                <a16:creationId xmlns:a16="http://schemas.microsoft.com/office/drawing/2014/main" id="{4526414A-01E8-4B22-B5DA-599CB6D1F420}"/>
               </a:ext>
             </a:extLst>
           </p:cNvPr>
@@ -4288,7 +4288,7 @@
           <p:cNvPr id="8" name="05">
             <a:extLst xmlns:a="http://schemas.openxmlformats.org/drawingml/2006/main">
               <a:ext uri="{FF2B5EF4-FFF2-40B4-BE49-F238E27FC236}">
-                <a16:creationId xmlns:a16="http://schemas.microsoft.com/office/drawing/2014/main" id="{1A3898DF-E8C6-4E74-BFE1-D0587E7AD225}"/>
+                <a16:creationId xmlns:a16="http://schemas.microsoft.com/office/drawing/2014/main" id="{8DF2678A-88C2-43DB-98F3-3F11D47D7A16}"/>
               </a:ext>
             </a:extLst>
           </p:cNvPr>
@@ -4343,7 +4343,7 @@
     </p:spTree>
     <p:extLst>
       <p:ext uri="{BB962C8B-B14F-4D97-AF65-F5344CB8AC3E}">
-        <p14:creationId xmlns:p14="http://schemas.microsoft.com/office/powerpoint/2010/main" val="1899809556"/>
+        <p14:creationId xmlns:p14="http://schemas.microsoft.com/office/powerpoint/2010/main" val="1275018554"/>
       </p:ext>
     </p:extLst>
   </p:cSld>
@@ -4374,7 +4374,7 @@
           <p:cNvPr id="5" name="DEMO">
             <a:extLst xmlns:a="http://schemas.openxmlformats.org/drawingml/2006/main">
               <a:ext uri="{FF2B5EF4-FFF2-40B4-BE49-F238E27FC236}">
-                <a16:creationId xmlns:a16="http://schemas.microsoft.com/office/drawing/2014/main" id="{06E7A693-1D0D-4E72-81DB-EF5A4D603C41}"/>
+                <a16:creationId xmlns:a16="http://schemas.microsoft.com/office/drawing/2014/main" id="{441F285B-F9C1-40F6-AEB8-18FFF128A635}"/>
               </a:ext>
             </a:extLst>
           </p:cNvPr>
@@ -4435,7 +4435,7 @@
           <p:nvPr/>
         </p:nvPicPr>
         <p:blipFill>
-          <a:blip xmlns:r="http://schemas.openxmlformats.org/officeDocument/2006/relationships" xmlns:a="http://schemas.openxmlformats.org/drawingml/2006/main" r:embed="R36ce049c2c5040ba"/>
+          <a:blip xmlns:r="http://schemas.openxmlformats.org/officeDocument/2006/relationships" xmlns:a="http://schemas.openxmlformats.org/drawingml/2006/main" r:embed="Rcc23d120dce840d1"/>
           <a:stretch xmlns:a="http://schemas.openxmlformats.org/drawingml/2006/main"/>
         </p:blipFill>
         <p:spPr>
@@ -4453,7 +4453,7 @@
           <p:cNvPr id="3" name="A little discovery, in the real world">
             <a:extLst xmlns:a="http://schemas.openxmlformats.org/drawingml/2006/main">
               <a:ext uri="{FF2B5EF4-FFF2-40B4-BE49-F238E27FC236}">
-                <a16:creationId xmlns:a16="http://schemas.microsoft.com/office/drawing/2014/main" id="{A94B4B20-186B-4F00-9922-43FFE8C3579E}"/>
+                <a16:creationId xmlns:a16="http://schemas.microsoft.com/office/drawing/2014/main" id="{3EB12EC4-8681-41FE-A48A-06360CC9CC41}"/>
               </a:ext>
             </a:extLst>
           </p:cNvPr>
@@ -4510,7 +4510,7 @@
           <p:cNvPr id="4" name="06">
             <a:extLst xmlns:a="http://schemas.openxmlformats.org/drawingml/2006/main">
               <a:ext uri="{FF2B5EF4-FFF2-40B4-BE49-F238E27FC236}">
-                <a16:creationId xmlns:a16="http://schemas.microsoft.com/office/drawing/2014/main" id="{38850924-AD1D-45B7-B5F3-D4EAC1711B53}"/>
+                <a16:creationId xmlns:a16="http://schemas.microsoft.com/office/drawing/2014/main" id="{5B5D711F-D091-4EF9-9D2A-8A44455FD272}"/>
               </a:ext>
             </a:extLst>
           </p:cNvPr>
@@ -4565,7 +4565,7 @@
     </p:spTree>
     <p:extLst>
       <p:ext uri="{BB962C8B-B14F-4D97-AF65-F5344CB8AC3E}">
-        <p14:creationId xmlns:p14="http://schemas.microsoft.com/office/powerpoint/2010/main" val="1752351793"/>
+        <p14:creationId xmlns:p14="http://schemas.microsoft.com/office/powerpoint/2010/main" val="153072154"/>
       </p:ext>
     </p:extLst>
   </p:cSld>
@@ -4596,7 +4596,7 @@
           <p:cNvPr id="12" name="How it works">
             <a:extLst xmlns:a="http://schemas.openxmlformats.org/drawingml/2006/main">
               <a:ext uri="{FF2B5EF4-FFF2-40B4-BE49-F238E27FC236}">
-                <a16:creationId xmlns:a16="http://schemas.microsoft.com/office/drawing/2014/main" id="{E84FAE9A-6F1E-494B-9226-20B862DCE568}"/>
+                <a16:creationId xmlns:a16="http://schemas.microsoft.com/office/drawing/2014/main" id="{41213608-2D13-4938-ADA8-9E6C53516F94}"/>
               </a:ext>
             </a:extLst>
           </p:cNvPr>
@@ -4653,7 +4653,7 @@
           <p:cNvPr id="2" name="Unity + ARKit">
             <a:extLst xmlns:a="http://schemas.openxmlformats.org/drawingml/2006/main">
               <a:ext uri="{FF2B5EF4-FFF2-40B4-BE49-F238E27FC236}">
-                <a16:creationId xmlns:a16="http://schemas.microsoft.com/office/drawing/2014/main" id="{42842688-7C30-4118-8D4D-A602A52FD5F0}"/>
+                <a16:creationId xmlns:a16="http://schemas.microsoft.com/office/drawing/2014/main" id="{F2BA6F1A-B111-4D70-B462-83B1D06F20C3}"/>
               </a:ext>
             </a:extLst>
           </p:cNvPr>
@@ -4710,7 +4710,7 @@
           <p:cNvPr id="3" name="Place and recover stickers in AR">
             <a:extLst xmlns:a="http://schemas.openxmlformats.org/drawingml/2006/main">
               <a:ext uri="{FF2B5EF4-FFF2-40B4-BE49-F238E27FC236}">
-                <a16:creationId xmlns:a16="http://schemas.microsoft.com/office/drawing/2014/main" id="{D0961ECF-BA39-453D-9400-E64AA58439E9}"/>
+                <a16:creationId xmlns:a16="http://schemas.microsoft.com/office/drawing/2014/main" id="{A24A528F-2537-4F6E-A1F8-F17D8A4407A3}"/>
               </a:ext>
             </a:extLst>
           </p:cNvPr>
@@ -4767,7 +4767,7 @@
           <p:cNvPr id="4" name="MapKit">
             <a:extLst xmlns:a="http://schemas.openxmlformats.org/drawingml/2006/main">
               <a:ext uri="{FF2B5EF4-FFF2-40B4-BE49-F238E27FC236}">
-                <a16:creationId xmlns:a16="http://schemas.microsoft.com/office/drawing/2014/main" id="{F0A70D8D-E84C-4EA4-B671-5DB2467F7C5A}"/>
+                <a16:creationId xmlns:a16="http://schemas.microsoft.com/office/drawing/2014/main" id="{C32C9103-69EA-445F-81F3-B89E5DB42CD2}"/>
               </a:ext>
             </a:extLst>
           </p:cNvPr>
@@ -4824,7 +4824,7 @@
           <p:cNvPr id="5" name="Nearby discovery on Apple’s maps">
             <a:extLst xmlns:a="http://schemas.openxmlformats.org/drawingml/2006/main">
               <a:ext uri="{FF2B5EF4-FFF2-40B4-BE49-F238E27FC236}">
-                <a16:creationId xmlns:a16="http://schemas.microsoft.com/office/drawing/2014/main" id="{8E6C682A-4033-4841-91FC-EA575793A02D}"/>
+                <a16:creationId xmlns:a16="http://schemas.microsoft.com/office/drawing/2014/main" id="{5558A5DC-B9E3-4CC7-A88D-08AD7D478D3B}"/>
               </a:ext>
             </a:extLst>
           </p:cNvPr>
@@ -4881,7 +4881,7 @@
           <p:cNvPr id="6" name="Firebase + Cloud Run">
             <a:extLst xmlns:a="http://schemas.openxmlformats.org/drawingml/2006/main">
               <a:ext uri="{FF2B5EF4-FFF2-40B4-BE49-F238E27FC236}">
-                <a16:creationId xmlns:a16="http://schemas.microsoft.com/office/drawing/2014/main" id="{AF8B48DB-296B-4F2B-9E00-49FF0DA3F731}"/>
+                <a16:creationId xmlns:a16="http://schemas.microsoft.com/office/drawing/2014/main" id="{6F2C95A7-A70F-467A-AD84-C58ADEFCBB8C}"/>
               </a:ext>
             </a:extLst>
           </p:cNvPr>
@@ -4938,7 +4938,7 @@
           <p:cNvPr id="7" name="Stickers, collections and private notes">
             <a:extLst xmlns:a="http://schemas.openxmlformats.org/drawingml/2006/main">
               <a:ext uri="{FF2B5EF4-FFF2-40B4-BE49-F238E27FC236}">
-                <a16:creationId xmlns:a16="http://schemas.microsoft.com/office/drawing/2014/main" id="{75E23F27-04A3-4C09-B2D5-C50C0292388C}"/>
+                <a16:creationId xmlns:a16="http://schemas.microsoft.com/office/drawing/2014/main" id="{C418BC48-6811-47D2-BD4D-2E5C01C05CFC}"/>
               </a:ext>
             </a:extLst>
           </p:cNvPr>
@@ -4999,7 +4999,7 @@
           <p:nvPr/>
         </p:nvPicPr>
         <p:blipFill>
-          <a:blip xmlns:r="http://schemas.openxmlformats.org/officeDocument/2006/relationships" xmlns:a="http://schemas.openxmlformats.org/drawingml/2006/main" r:embed="R2db394a46445471d"/>
+          <a:blip xmlns:r="http://schemas.openxmlformats.org/officeDocument/2006/relationships" xmlns:a="http://schemas.openxmlformats.org/drawingml/2006/main" r:embed="R88078efe2c984adf"/>
           <a:stretch xmlns:a="http://schemas.openxmlformats.org/drawingml/2006/main"/>
         </p:blipFill>
         <p:spPr>
@@ -5017,7 +5017,7 @@
           <p:cNvPr id="9" name="On chain souvenirs">
             <a:extLst xmlns:a="http://schemas.openxmlformats.org/drawingml/2006/main">
               <a:ext uri="{FF2B5EF4-FFF2-40B4-BE49-F238E27FC236}">
-                <a16:creationId xmlns:a16="http://schemas.microsoft.com/office/drawing/2014/main" id="{F49427DD-3AEE-4D5D-BA60-CAA7830324F5}"/>
+                <a16:creationId xmlns:a16="http://schemas.microsoft.com/office/drawing/2014/main" id="{A5CE6ABE-C464-4697-8DF1-ED1E20F29BF8}"/>
               </a:ext>
             </a:extLst>
           </p:cNvPr>
@@ -5074,7 +5074,7 @@
           <p:cNvPr id="10" name="Already implemented">
             <a:extLst xmlns:a="http://schemas.openxmlformats.org/drawingml/2006/main">
               <a:ext uri="{FF2B5EF4-FFF2-40B4-BE49-F238E27FC236}">
-                <a16:creationId xmlns:a16="http://schemas.microsoft.com/office/drawing/2014/main" id="{53C31EE2-7B22-4ECA-AB91-9C6E50107932}"/>
+                <a16:creationId xmlns:a16="http://schemas.microsoft.com/office/drawing/2014/main" id="{6AC8CE97-9EE9-46FC-A362-8D0E3514DDFE}"/>
               </a:ext>
             </a:extLst>
           </p:cNvPr>
@@ -5131,7 +5131,7 @@
           <p:cNvPr id="11" name="07">
             <a:extLst xmlns:a="http://schemas.openxmlformats.org/drawingml/2006/main">
               <a:ext uri="{FF2B5EF4-FFF2-40B4-BE49-F238E27FC236}">
-                <a16:creationId xmlns:a16="http://schemas.microsoft.com/office/drawing/2014/main" id="{3F936674-2325-4AA4-99B6-D7CAE694FC49}"/>
+                <a16:creationId xmlns:a16="http://schemas.microsoft.com/office/drawing/2014/main" id="{4F9E6359-313D-47E9-9FBA-EA186270774D}"/>
               </a:ext>
             </a:extLst>
           </p:cNvPr>
@@ -5186,7 +5186,7 @@
     </p:spTree>
     <p:extLst>
       <p:ext uri="{BB962C8B-B14F-4D97-AF65-F5344CB8AC3E}">
-        <p14:creationId xmlns:p14="http://schemas.microsoft.com/office/powerpoint/2010/main" val="1980151517"/>
+        <p14:creationId xmlns:p14="http://schemas.microsoft.com/office/powerpoint/2010/main" val="1319170583"/>
       </p:ext>
     </p:extLst>
   </p:cSld>
@@ -5217,7 +5217,7 @@
           <p:cNvPr id="6" name="The first&#10;community pilot">
             <a:extLst xmlns:a="http://schemas.openxmlformats.org/drawingml/2006/main">
               <a:ext uri="{FF2B5EF4-FFF2-40B4-BE49-F238E27FC236}">
-                <a16:creationId xmlns:a16="http://schemas.microsoft.com/office/drawing/2014/main" id="{F5424F38-784C-4E7C-9763-052F0A0E6F6D}"/>
+                <a16:creationId xmlns:a16="http://schemas.microsoft.com/office/drawing/2014/main" id="{2E2CE34E-DF73-475B-8AC7-8E55F2780B22}"/>
               </a:ext>
             </a:extLst>
           </p:cNvPr>
@@ -5297,7 +5297,7 @@
           <p:cNvPr id="2" name="A small trail of meaningful places.&#10;Original stickers f">
             <a:extLst xmlns:a="http://schemas.openxmlformats.org/drawingml/2006/main">
               <a:ext uri="{FF2B5EF4-FFF2-40B4-BE49-F238E27FC236}">
-                <a16:creationId xmlns:a16="http://schemas.microsoft.com/office/drawing/2014/main" id="{C1A6CFFB-3D46-4490-B8B2-D05D8FC690EE}"/>
+                <a16:creationId xmlns:a16="http://schemas.microsoft.com/office/drawing/2014/main" id="{EFB1E042-1AB0-46AE-95D0-E472DABA367E}"/>
               </a:ext>
             </a:extLst>
           </p:cNvPr>
@@ -5400,7 +5400,7 @@
           <p:cNvPr id="3" name="Learn: do people finish, and return?">
             <a:extLst xmlns:a="http://schemas.openxmlformats.org/drawingml/2006/main">
               <a:ext uri="{FF2B5EF4-FFF2-40B4-BE49-F238E27FC236}">
-                <a16:creationId xmlns:a16="http://schemas.microsoft.com/office/drawing/2014/main" id="{CE4F8442-871E-4CFE-87AA-4EEFFCF30E74}"/>
+                <a16:creationId xmlns:a16="http://schemas.microsoft.com/office/drawing/2014/main" id="{3EE11B32-960F-4196-8671-32260A5DD81D}"/>
               </a:ext>
             </a:extLst>
           </p:cNvPr>
@@ -5461,7 +5461,7 @@
           <p:nvPr/>
         </p:nvPicPr>
         <p:blipFill>
-          <a:blip xmlns:r="http://schemas.openxmlformats.org/officeDocument/2006/relationships" xmlns:a="http://schemas.openxmlformats.org/drawingml/2006/main" r:embed="R816f38f94c974187"/>
+          <a:blip xmlns:r="http://schemas.openxmlformats.org/officeDocument/2006/relationships" xmlns:a="http://schemas.openxmlformats.org/drawingml/2006/main" r:embed="R4cb7686256d84a42"/>
           <a:stretch xmlns:a="http://schemas.openxmlformats.org/drawingml/2006/main"/>
         </p:blipFill>
         <p:spPr>
@@ -5479,7 +5479,7 @@
           <p:cNvPr id="5" name="08">
             <a:extLst xmlns:a="http://schemas.openxmlformats.org/drawingml/2006/main">
               <a:ext uri="{FF2B5EF4-FFF2-40B4-BE49-F238E27FC236}">
-                <a16:creationId xmlns:a16="http://schemas.microsoft.com/office/drawing/2014/main" id="{A03A684B-7F90-4E51-AEFF-7AADC8E13EE2}"/>
+                <a16:creationId xmlns:a16="http://schemas.microsoft.com/office/drawing/2014/main" id="{E9B65F82-25D6-4FBD-9C42-DE2DB6791A62}"/>
               </a:ext>
             </a:extLst>
           </p:cNvPr>
@@ -5534,7 +5534,7 @@
     </p:spTree>
     <p:extLst>
       <p:ext uri="{BB962C8B-B14F-4D97-AF65-F5344CB8AC3E}">
-        <p14:creationId xmlns:p14="http://schemas.microsoft.com/office/powerpoint/2010/main" val="2027664844"/>
+        <p14:creationId xmlns:p14="http://schemas.microsoft.com/office/powerpoint/2010/main" val="1411654182"/>
       </p:ext>
     </p:extLst>
   </p:cSld>
@@ -5565,7 +5565,7 @@
           <p:cNvPr id="6" name="Find your places.&#10;Collect your moments.">
             <a:extLst xmlns:a="http://schemas.openxmlformats.org/drawingml/2006/main">
               <a:ext uri="{FF2B5EF4-FFF2-40B4-BE49-F238E27FC236}">
-                <a16:creationId xmlns:a16="http://schemas.microsoft.com/office/drawing/2014/main" id="{682D0EF7-E994-4EEA-9600-24183738FA13}"/>
+                <a16:creationId xmlns:a16="http://schemas.microsoft.com/office/drawing/2014/main" id="{D899A5B9-E96A-4009-ABB7-07584D60F1CF}"/>
               </a:ext>
             </a:extLst>
           </p:cNvPr>
@@ -5645,7 +5645,7 @@
           <p:cNvPr id="2" name="Let’s create the first&#10;community trail together.">
             <a:extLst xmlns:a="http://schemas.openxmlformats.org/drawingml/2006/main">
               <a:ext uri="{FF2B5EF4-FFF2-40B4-BE49-F238E27FC236}">
-                <a16:creationId xmlns:a16="http://schemas.microsoft.com/office/drawing/2014/main" id="{7DD0D7C0-7458-4B1F-AF96-C1891013EA21}"/>
+                <a16:creationId xmlns:a16="http://schemas.microsoft.com/office/drawing/2014/main" id="{5D924D27-E2A8-42F6-957A-D89F690FDE23}"/>
               </a:ext>
             </a:extLst>
           </p:cNvPr>
@@ -5729,7 +5729,7 @@
           <p:nvPr/>
         </p:nvPicPr>
         <p:blipFill>
-          <a:blip xmlns:r="http://schemas.openxmlformats.org/officeDocument/2006/relationships" xmlns:a="http://schemas.openxmlformats.org/drawingml/2006/main" r:embed="R3e8160c7f24b4925"/>
+          <a:blip xmlns:r="http://schemas.openxmlformats.org/officeDocument/2006/relationships" xmlns:a="http://schemas.openxmlformats.org/drawingml/2006/main" r:embed="Rffc17253342b4880"/>
           <a:stretch xmlns:a="http://schemas.openxmlformats.org/drawingml/2006/main"/>
         </p:blipFill>
         <p:spPr>
@@ -5747,7 +5747,7 @@
           <p:cNvPr id="4" name="tagtag">
             <a:extLst xmlns:a="http://schemas.openxmlformats.org/drawingml/2006/main">
               <a:ext uri="{FF2B5EF4-FFF2-40B4-BE49-F238E27FC236}">
-                <a16:creationId xmlns:a16="http://schemas.microsoft.com/office/drawing/2014/main" id="{982D45C1-8A2E-45CD-BC65-EEF5084A77F4}"/>
+                <a16:creationId xmlns:a16="http://schemas.microsoft.com/office/drawing/2014/main" id="{AB097964-C0BC-4BC4-B161-0D9784CB42AE}"/>
               </a:ext>
             </a:extLst>
           </p:cNvPr>
@@ -5804,7 +5804,7 @@
           <p:cNvPr id="5" name="09">
             <a:extLst xmlns:a="http://schemas.openxmlformats.org/drawingml/2006/main">
               <a:ext uri="{FF2B5EF4-FFF2-40B4-BE49-F238E27FC236}">
-                <a16:creationId xmlns:a16="http://schemas.microsoft.com/office/drawing/2014/main" id="{32A9A483-8EEB-441B-8F7C-D08BC2E4079A}"/>
+                <a16:creationId xmlns:a16="http://schemas.microsoft.com/office/drawing/2014/main" id="{DA91E18C-D037-4BF4-8926-4B075A93D664}"/>
               </a:ext>
             </a:extLst>
           </p:cNvPr>
@@ -5859,7 +5859,7 @@
     </p:spTree>
     <p:extLst>
       <p:ext uri="{BB962C8B-B14F-4D97-AF65-F5344CB8AC3E}">
-        <p14:creationId xmlns:p14="http://schemas.microsoft.com/office/powerpoint/2010/main" val="769840966"/>
+        <p14:creationId xmlns:p14="http://schemas.microsoft.com/office/powerpoint/2010/main" val="1198284475"/>
       </p:ext>
     </p:extLst>
   </p:cSld>

</xml_diff>